<commit_message>
Update documentation and add new files for Nexys version of RISC-V MCU
</commit_message>
<xml_diff>
--- a/Intro/RISCV-MCU.pptx
+++ b/Intro/RISCV-MCU.pptx
@@ -13,7 +13,7 @@
     <p:sldMasterId id="2147483668" r:id="rId9"/>
   </p:sldMasterIdLst>
   <p:notesMasterIdLst>
-    <p:notesMasterId r:id="rId31"/>
+    <p:notesMasterId r:id="rId32"/>
   </p:notesMasterIdLst>
   <p:sldIdLst>
     <p:sldId id="256" r:id="rId10"/>
@@ -21,22 +21,23 @@
     <p:sldId id="278" r:id="rId12"/>
     <p:sldId id="279" r:id="rId13"/>
     <p:sldId id="257" r:id="rId14"/>
-    <p:sldId id="271" r:id="rId15"/>
-    <p:sldId id="282" r:id="rId16"/>
-    <p:sldId id="285" r:id="rId17"/>
-    <p:sldId id="284" r:id="rId18"/>
-    <p:sldId id="286" r:id="rId19"/>
-    <p:sldId id="283" r:id="rId20"/>
-    <p:sldId id="273" r:id="rId21"/>
-    <p:sldId id="275" r:id="rId22"/>
-    <p:sldId id="290" r:id="rId23"/>
-    <p:sldId id="263" r:id="rId24"/>
-    <p:sldId id="272" r:id="rId25"/>
-    <p:sldId id="289" r:id="rId26"/>
-    <p:sldId id="280" r:id="rId27"/>
-    <p:sldId id="281" r:id="rId28"/>
-    <p:sldId id="264" r:id="rId29"/>
-    <p:sldId id="287" r:id="rId30"/>
+    <p:sldId id="291" r:id="rId15"/>
+    <p:sldId id="271" r:id="rId16"/>
+    <p:sldId id="282" r:id="rId17"/>
+    <p:sldId id="285" r:id="rId18"/>
+    <p:sldId id="284" r:id="rId19"/>
+    <p:sldId id="286" r:id="rId20"/>
+    <p:sldId id="283" r:id="rId21"/>
+    <p:sldId id="273" r:id="rId22"/>
+    <p:sldId id="275" r:id="rId23"/>
+    <p:sldId id="290" r:id="rId24"/>
+    <p:sldId id="263" r:id="rId25"/>
+    <p:sldId id="272" r:id="rId26"/>
+    <p:sldId id="289" r:id="rId27"/>
+    <p:sldId id="280" r:id="rId28"/>
+    <p:sldId id="281" r:id="rId29"/>
+    <p:sldId id="264" r:id="rId30"/>
+    <p:sldId id="287" r:id="rId31"/>
   </p:sldIdLst>
   <p:sldSz cx="12192000" cy="6858000"/>
   <p:notesSz cx="6858000" cy="9144000"/>
@@ -10476,6 +10477,818 @@
         <p:cNvPr id="1" name="">
           <a:extLst>
             <a:ext uri="{FF2B5EF4-FFF2-40B4-BE49-F238E27FC236}">
+              <a16:creationId xmlns:a16="http://schemas.microsoft.com/office/drawing/2014/main" id="{DC1012D1-F0FF-7EB7-E797-745506D78940}"/>
+            </a:ext>
+          </a:extLst>
+        </p:cNvPr>
+        <p:cNvGrpSpPr/>
+        <p:nvPr/>
+      </p:nvGrpSpPr>
+      <p:grpSpPr>
+        <a:xfrm>
+          <a:off x="0" y="0"/>
+          <a:ext cx="0" cy="0"/>
+          <a:chOff x="0" y="0"/>
+          <a:chExt cx="0" cy="0"/>
+        </a:xfrm>
+      </p:grpSpPr>
+      <p:sp>
+        <p:nvSpPr>
+          <p:cNvPr id="69" name="PlaceHolder 1">
+            <a:extLst>
+              <a:ext uri="{FF2B5EF4-FFF2-40B4-BE49-F238E27FC236}">
+                <a16:creationId xmlns:a16="http://schemas.microsoft.com/office/drawing/2014/main" id="{C6B8070D-A6BE-BFD9-30C0-33B6542AFD2B}"/>
+              </a:ext>
+            </a:extLst>
+          </p:cNvPr>
+          <p:cNvSpPr>
+            <a:spLocks noGrp="1"/>
+          </p:cNvSpPr>
+          <p:nvPr>
+            <p:ph type="title"/>
+          </p:nvPr>
+        </p:nvSpPr>
+        <p:spPr>
+          <a:xfrm>
+            <a:off x="1015920" y="0"/>
+            <a:ext cx="10972080" cy="1142280"/>
+          </a:xfrm>
+          <a:prstGeom prst="rect">
+            <a:avLst/>
+          </a:prstGeom>
+          <a:noFill/>
+          <a:ln w="0">
+            <a:noFill/>
+          </a:ln>
+        </p:spPr>
+        <p:txBody>
+          <a:bodyPr lIns="91440" tIns="45720" rIns="91440" bIns="45720" anchor="ctr">
+            <a:noAutofit/>
+          </a:bodyPr>
+          <a:lstStyle/>
+          <a:p>
+            <a:pPr>
+              <a:lnSpc>
+                <a:spcPct val="100000"/>
+              </a:lnSpc>
+              <a:tabLst>
+                <a:tab pos="0" algn="l"/>
+              </a:tabLst>
+            </a:pPr>
+            <a:r>
+              <a:rPr lang="en-US" sz="4000" b="1" spc="-1" dirty="0">
+                <a:solidFill>
+                  <a:srgbClr val="DDDDDD"/>
+                </a:solidFill>
+                <a:latin typeface="Calibri"/>
+                <a:ea typeface="Calibri"/>
+              </a:rPr>
+              <a:t>UART</a:t>
+            </a:r>
+            <a:endParaRPr lang="en-US" sz="4000" b="0" strike="noStrike" spc="-1" dirty="0">
+              <a:solidFill>
+                <a:srgbClr val="000000"/>
+              </a:solidFill>
+              <a:latin typeface="Arial"/>
+            </a:endParaRPr>
+          </a:p>
+        </p:txBody>
+      </p:sp>
+      <p:sp>
+        <p:nvSpPr>
+          <p:cNvPr id="8" name="矩形 12">
+            <a:extLst>
+              <a:ext uri="{FF2B5EF4-FFF2-40B4-BE49-F238E27FC236}">
+                <a16:creationId xmlns:a16="http://schemas.microsoft.com/office/drawing/2014/main" id="{9C7DCEBE-7CDA-83B2-3426-76BAAAE03F13}"/>
+              </a:ext>
+            </a:extLst>
+          </p:cNvPr>
+          <p:cNvSpPr/>
+          <p:nvPr/>
+        </p:nvSpPr>
+        <p:spPr>
+          <a:xfrm rot="16200000">
+            <a:off x="-1501832" y="3976268"/>
+            <a:ext cx="4367745" cy="254880"/>
+          </a:xfrm>
+          <a:prstGeom prst="rect">
+            <a:avLst/>
+          </a:prstGeom>
+          <a:solidFill>
+            <a:schemeClr val="tx1"/>
+          </a:solidFill>
+          <a:ln>
+            <a:solidFill>
+              <a:srgbClr val="516263"/>
+            </a:solidFill>
+            <a:round/>
+          </a:ln>
+        </p:spPr>
+        <p:style>
+          <a:lnRef idx="2">
+            <a:schemeClr val="accent1">
+              <a:shade val="15000"/>
+            </a:schemeClr>
+          </a:lnRef>
+          <a:fillRef idx="1">
+            <a:schemeClr val="accent1"/>
+          </a:fillRef>
+          <a:effectRef idx="0">
+            <a:schemeClr val="accent1"/>
+          </a:effectRef>
+          <a:fontRef idx="minor"/>
+        </p:style>
+        <p:txBody>
+          <a:bodyPr lIns="90000" tIns="45000" rIns="90000" bIns="45000" anchor="ctr">
+            <a:noAutofit/>
+          </a:bodyPr>
+          <a:lstStyle/>
+          <a:p>
+            <a:pPr algn="ctr">
+              <a:lnSpc>
+                <a:spcPct val="100000"/>
+              </a:lnSpc>
+            </a:pPr>
+            <a:r>
+              <a:rPr lang="en-US" sz="2000" b="0" strike="noStrike" spc="-1">
+                <a:solidFill>
+                  <a:schemeClr val="lt1"/>
+                </a:solidFill>
+                <a:latin typeface="Arial"/>
+                <a:ea typeface="Arial"/>
+              </a:rPr>
+              <a:t>AXI Interconnect (BUS)</a:t>
+            </a:r>
+            <a:endParaRPr lang="en-US" sz="2000" b="0" strike="noStrike" spc="-1">
+              <a:solidFill>
+                <a:srgbClr val="FFFFFF"/>
+              </a:solidFill>
+              <a:latin typeface="Arial"/>
+            </a:endParaRPr>
+          </a:p>
+        </p:txBody>
+      </p:sp>
+      <p:sp>
+        <p:nvSpPr>
+          <p:cNvPr id="15" name="箭號: 上-下雙向 14">
+            <a:extLst>
+              <a:ext uri="{FF2B5EF4-FFF2-40B4-BE49-F238E27FC236}">
+                <a16:creationId xmlns:a16="http://schemas.microsoft.com/office/drawing/2014/main" id="{03CC0EE7-32EF-09E8-560E-B31180B8CE08}"/>
+              </a:ext>
+            </a:extLst>
+          </p:cNvPr>
+          <p:cNvSpPr/>
+          <p:nvPr/>
+        </p:nvSpPr>
+        <p:spPr>
+          <a:xfrm rot="16200000">
+            <a:off x="1233947" y="2016530"/>
+            <a:ext cx="429062" cy="902821"/>
+          </a:xfrm>
+          <a:prstGeom prst="upDownArrow">
+            <a:avLst/>
+          </a:prstGeom>
+          <a:solidFill>
+            <a:schemeClr val="tx1"/>
+          </a:solidFill>
+        </p:spPr>
+        <p:style>
+          <a:lnRef idx="2">
+            <a:schemeClr val="accent1">
+              <a:shade val="15000"/>
+            </a:schemeClr>
+          </a:lnRef>
+          <a:fillRef idx="1">
+            <a:schemeClr val="accent1"/>
+          </a:fillRef>
+          <a:effectRef idx="0">
+            <a:schemeClr val="accent1"/>
+          </a:effectRef>
+          <a:fontRef idx="minor">
+            <a:schemeClr val="lt1"/>
+          </a:fontRef>
+        </p:style>
+        <p:txBody>
+          <a:bodyPr rtlCol="0" anchor="ctr"/>
+          <a:lstStyle/>
+          <a:p>
+            <a:pPr algn="ctr"/>
+            <a:endParaRPr lang="en-US"/>
+          </a:p>
+        </p:txBody>
+      </p:sp>
+      <p:sp>
+        <p:nvSpPr>
+          <p:cNvPr id="16" name="箭號: 上-下雙向 15">
+            <a:extLst>
+              <a:ext uri="{FF2B5EF4-FFF2-40B4-BE49-F238E27FC236}">
+                <a16:creationId xmlns:a16="http://schemas.microsoft.com/office/drawing/2014/main" id="{095BAD7F-A724-D31B-0A50-76863E2DD21D}"/>
+              </a:ext>
+            </a:extLst>
+          </p:cNvPr>
+          <p:cNvSpPr/>
+          <p:nvPr/>
+        </p:nvSpPr>
+        <p:spPr>
+          <a:xfrm rot="16200000">
+            <a:off x="1233948" y="4995398"/>
+            <a:ext cx="429062" cy="902821"/>
+          </a:xfrm>
+          <a:prstGeom prst="upDownArrow">
+            <a:avLst/>
+          </a:prstGeom>
+          <a:solidFill>
+            <a:schemeClr val="tx1"/>
+          </a:solidFill>
+        </p:spPr>
+        <p:style>
+          <a:lnRef idx="2">
+            <a:schemeClr val="accent1">
+              <a:shade val="15000"/>
+            </a:schemeClr>
+          </a:lnRef>
+          <a:fillRef idx="1">
+            <a:schemeClr val="accent1"/>
+          </a:fillRef>
+          <a:effectRef idx="0">
+            <a:schemeClr val="accent1"/>
+          </a:effectRef>
+          <a:fontRef idx="minor">
+            <a:schemeClr val="lt1"/>
+          </a:fontRef>
+        </p:style>
+        <p:txBody>
+          <a:bodyPr rtlCol="0" anchor="ctr"/>
+          <a:lstStyle/>
+          <a:p>
+            <a:pPr algn="ctr"/>
+            <a:endParaRPr lang="en-US"/>
+          </a:p>
+        </p:txBody>
+      </p:sp>
+      <p:sp>
+        <p:nvSpPr>
+          <p:cNvPr id="18" name="矩形: 圓角 23">
+            <a:extLst>
+              <a:ext uri="{FF2B5EF4-FFF2-40B4-BE49-F238E27FC236}">
+                <a16:creationId xmlns:a16="http://schemas.microsoft.com/office/drawing/2014/main" id="{62093F4C-913F-6215-7CAB-2DDC0EB27C95}"/>
+              </a:ext>
+            </a:extLst>
+          </p:cNvPr>
+          <p:cNvSpPr/>
+          <p:nvPr/>
+        </p:nvSpPr>
+        <p:spPr>
+          <a:xfrm>
+            <a:off x="1999995" y="1919835"/>
+            <a:ext cx="1209600" cy="1045080"/>
+          </a:xfrm>
+          <a:prstGeom prst="roundRect">
+            <a:avLst>
+              <a:gd name="adj" fmla="val 16667"/>
+            </a:avLst>
+          </a:prstGeom>
+          <a:solidFill>
+            <a:srgbClr val="92D050"/>
+          </a:solidFill>
+          <a:ln>
+            <a:solidFill>
+              <a:srgbClr val="516263"/>
+            </a:solidFill>
+            <a:round/>
+          </a:ln>
+        </p:spPr>
+        <p:style>
+          <a:lnRef idx="2">
+            <a:schemeClr val="accent1">
+              <a:shade val="15000"/>
+            </a:schemeClr>
+          </a:lnRef>
+          <a:fillRef idx="1">
+            <a:schemeClr val="accent1"/>
+          </a:fillRef>
+          <a:effectRef idx="0">
+            <a:schemeClr val="accent1"/>
+          </a:effectRef>
+          <a:fontRef idx="minor"/>
+        </p:style>
+        <p:txBody>
+          <a:bodyPr lIns="90000" tIns="45000" rIns="90000" bIns="45000" anchor="ctr">
+            <a:noAutofit/>
+          </a:bodyPr>
+          <a:lstStyle/>
+          <a:p>
+            <a:pPr algn="ctr">
+              <a:lnSpc>
+                <a:spcPct val="100000"/>
+              </a:lnSpc>
+            </a:pPr>
+            <a:r>
+              <a:rPr lang="en-US" sz="1400" b="0" strike="noStrike" spc="-1" dirty="0">
+                <a:solidFill>
+                  <a:schemeClr val="dk1"/>
+                </a:solidFill>
+                <a:latin typeface="Arial"/>
+                <a:ea typeface="Arial"/>
+              </a:rPr>
+              <a:t>AXI UART</a:t>
+            </a:r>
+          </a:p>
+          <a:p>
+            <a:pPr algn="ctr">
+              <a:lnSpc>
+                <a:spcPct val="100000"/>
+              </a:lnSpc>
+            </a:pPr>
+            <a:r>
+              <a:rPr lang="en-US" altLang="zh-TW" sz="1400" spc="-1" dirty="0">
+                <a:solidFill>
+                  <a:schemeClr val="dk1"/>
+                </a:solidFill>
+                <a:latin typeface="Arial"/>
+              </a:rPr>
+              <a:t>16550</a:t>
+            </a:r>
+            <a:endParaRPr lang="en-US" sz="1400" b="0" strike="noStrike" spc="-1" dirty="0">
+              <a:solidFill>
+                <a:srgbClr val="000000"/>
+              </a:solidFill>
+              <a:latin typeface="Arial"/>
+            </a:endParaRPr>
+          </a:p>
+        </p:txBody>
+      </p:sp>
+      <p:sp>
+        <p:nvSpPr>
+          <p:cNvPr id="20" name="矩形: 圓角 23">
+            <a:extLst>
+              <a:ext uri="{FF2B5EF4-FFF2-40B4-BE49-F238E27FC236}">
+                <a16:creationId xmlns:a16="http://schemas.microsoft.com/office/drawing/2014/main" id="{F69C6085-5589-54F3-377E-839D25086485}"/>
+              </a:ext>
+            </a:extLst>
+          </p:cNvPr>
+          <p:cNvSpPr/>
+          <p:nvPr/>
+        </p:nvSpPr>
+        <p:spPr>
+          <a:xfrm>
+            <a:off x="1999995" y="4924268"/>
+            <a:ext cx="1209600" cy="1045080"/>
+          </a:xfrm>
+          <a:prstGeom prst="roundRect">
+            <a:avLst>
+              <a:gd name="adj" fmla="val 16667"/>
+            </a:avLst>
+          </a:prstGeom>
+          <a:solidFill>
+            <a:srgbClr val="92D050"/>
+          </a:solidFill>
+          <a:ln>
+            <a:solidFill>
+              <a:srgbClr val="516263"/>
+            </a:solidFill>
+            <a:round/>
+          </a:ln>
+        </p:spPr>
+        <p:style>
+          <a:lnRef idx="2">
+            <a:schemeClr val="accent1">
+              <a:shade val="15000"/>
+            </a:schemeClr>
+          </a:lnRef>
+          <a:fillRef idx="1">
+            <a:schemeClr val="accent1"/>
+          </a:fillRef>
+          <a:effectRef idx="0">
+            <a:schemeClr val="accent1"/>
+          </a:effectRef>
+          <a:fontRef idx="minor"/>
+        </p:style>
+        <p:txBody>
+          <a:bodyPr lIns="90000" tIns="45000" rIns="90000" bIns="45000" anchor="ctr">
+            <a:noAutofit/>
+          </a:bodyPr>
+          <a:lstStyle/>
+          <a:p>
+            <a:pPr algn="ctr">
+              <a:lnSpc>
+                <a:spcPct val="100000"/>
+              </a:lnSpc>
+            </a:pPr>
+            <a:r>
+              <a:rPr lang="en-US" sz="1400" b="0" strike="noStrike" spc="-1" dirty="0">
+                <a:solidFill>
+                  <a:schemeClr val="dk1"/>
+                </a:solidFill>
+                <a:latin typeface="Arial"/>
+                <a:ea typeface="Arial"/>
+              </a:rPr>
+              <a:t>AXI UART</a:t>
+            </a:r>
+          </a:p>
+          <a:p>
+            <a:pPr algn="ctr">
+              <a:lnSpc>
+                <a:spcPct val="100000"/>
+              </a:lnSpc>
+            </a:pPr>
+            <a:r>
+              <a:rPr lang="en-US" altLang="zh-TW" sz="1400" spc="-1" dirty="0">
+                <a:solidFill>
+                  <a:schemeClr val="dk1"/>
+                </a:solidFill>
+                <a:latin typeface="Arial"/>
+              </a:rPr>
+              <a:t>16550 * 2</a:t>
+            </a:r>
+            <a:endParaRPr lang="en-US" sz="1400" b="0" strike="noStrike" spc="-1" dirty="0">
+              <a:solidFill>
+                <a:srgbClr val="000000"/>
+              </a:solidFill>
+              <a:latin typeface="Arial"/>
+            </a:endParaRPr>
+          </a:p>
+        </p:txBody>
+      </p:sp>
+      <p:sp>
+        <p:nvSpPr>
+          <p:cNvPr id="21" name="文字方塊 22">
+            <a:extLst>
+              <a:ext uri="{FF2B5EF4-FFF2-40B4-BE49-F238E27FC236}">
+                <a16:creationId xmlns:a16="http://schemas.microsoft.com/office/drawing/2014/main" id="{3BD316AC-9B5D-106F-D34F-74A87F33A669}"/>
+              </a:ext>
+            </a:extLst>
+          </p:cNvPr>
+          <p:cNvSpPr/>
+          <p:nvPr/>
+        </p:nvSpPr>
+        <p:spPr>
+          <a:xfrm>
+            <a:off x="3799002" y="2289213"/>
+            <a:ext cx="2064989" cy="306323"/>
+          </a:xfrm>
+          <a:prstGeom prst="rect">
+            <a:avLst/>
+          </a:prstGeom>
+          <a:noFill/>
+          <a:ln w="0">
+            <a:noFill/>
+          </a:ln>
+        </p:spPr>
+        <p:style>
+          <a:lnRef idx="0">
+            <a:scrgbClr r="0" g="0" b="0"/>
+          </a:lnRef>
+          <a:fillRef idx="0">
+            <a:scrgbClr r="0" g="0" b="0"/>
+          </a:fillRef>
+          <a:effectRef idx="0">
+            <a:scrgbClr r="0" g="0" b="0"/>
+          </a:effectRef>
+          <a:fontRef idx="minor"/>
+        </p:style>
+        <p:txBody>
+          <a:bodyPr wrap="square" lIns="90000" tIns="45000" rIns="90000" bIns="45000" anchor="t">
+            <a:spAutoFit/>
+          </a:bodyPr>
+          <a:lstStyle/>
+          <a:p>
+            <a:pPr algn="ctr"/>
+            <a:r>
+              <a:rPr lang="en-US" sz="1400" b="0" strike="noStrike" spc="-1" dirty="0">
+                <a:solidFill>
+                  <a:srgbClr val="000000"/>
+                </a:solidFill>
+                <a:latin typeface="Arial"/>
+              </a:rPr>
+              <a:t>UART_R</a:t>
+            </a:r>
+            <a:r>
+              <a:rPr lang="en-US" sz="1400" spc="-1" dirty="0">
+                <a:solidFill>
+                  <a:srgbClr val="000000"/>
+                </a:solidFill>
+                <a:latin typeface="Arial"/>
+              </a:rPr>
+              <a:t>X / UART_TX</a:t>
+            </a:r>
+            <a:endParaRPr lang="en-US" sz="1400" b="0" strike="noStrike" spc="-1" dirty="0">
+              <a:solidFill>
+                <a:srgbClr val="000000"/>
+              </a:solidFill>
+              <a:latin typeface="Arial"/>
+            </a:endParaRPr>
+          </a:p>
+        </p:txBody>
+      </p:sp>
+      <p:cxnSp>
+        <p:nvCxnSpPr>
+          <p:cNvPr id="23" name="直線單箭頭接點 14">
+            <a:extLst>
+              <a:ext uri="{FF2B5EF4-FFF2-40B4-BE49-F238E27FC236}">
+                <a16:creationId xmlns:a16="http://schemas.microsoft.com/office/drawing/2014/main" id="{53BD1B6E-8B14-61E5-B5D3-FA1BEEE1FC87}"/>
+              </a:ext>
+            </a:extLst>
+          </p:cNvPr>
+          <p:cNvCxnSpPr>
+            <a:cxnSpLocks/>
+            <a:stCxn id="20" idx="3"/>
+            <a:endCxn id="35" idx="1"/>
+          </p:cNvCxnSpPr>
+          <p:nvPr/>
+        </p:nvCxnSpPr>
+        <p:spPr>
+          <a:xfrm>
+            <a:off x="3209595" y="5446808"/>
+            <a:ext cx="599508" cy="0"/>
+          </a:xfrm>
+          <a:prstGeom prst="straightConnector1">
+            <a:avLst/>
+          </a:prstGeom>
+          <a:ln w="0">
+            <a:solidFill>
+              <a:srgbClr val="000000"/>
+            </a:solidFill>
+            <a:tailEnd type="triangle" w="med" len="med"/>
+          </a:ln>
+        </p:spPr>
+      </p:cxnSp>
+      <p:cxnSp>
+        <p:nvCxnSpPr>
+          <p:cNvPr id="32" name="直線單箭頭接點 14">
+            <a:extLst>
+              <a:ext uri="{FF2B5EF4-FFF2-40B4-BE49-F238E27FC236}">
+                <a16:creationId xmlns:a16="http://schemas.microsoft.com/office/drawing/2014/main" id="{7D30910F-D8E7-2E59-AD42-746234317054}"/>
+              </a:ext>
+            </a:extLst>
+          </p:cNvPr>
+          <p:cNvCxnSpPr>
+            <a:cxnSpLocks/>
+            <a:stCxn id="18" idx="3"/>
+            <a:endCxn id="21" idx="1"/>
+          </p:cNvCxnSpPr>
+          <p:nvPr/>
+        </p:nvCxnSpPr>
+        <p:spPr>
+          <a:xfrm>
+            <a:off x="3209595" y="2442375"/>
+            <a:ext cx="589407" cy="0"/>
+          </a:xfrm>
+          <a:prstGeom prst="straightConnector1">
+            <a:avLst/>
+          </a:prstGeom>
+          <a:ln w="0">
+            <a:solidFill>
+              <a:srgbClr val="000000"/>
+            </a:solidFill>
+            <a:tailEnd type="triangle" w="med" len="med"/>
+          </a:ln>
+        </p:spPr>
+      </p:cxnSp>
+      <p:sp>
+        <p:nvSpPr>
+          <p:cNvPr id="35" name="文字方塊 22">
+            <a:extLst>
+              <a:ext uri="{FF2B5EF4-FFF2-40B4-BE49-F238E27FC236}">
+                <a16:creationId xmlns:a16="http://schemas.microsoft.com/office/drawing/2014/main" id="{7CBA17DF-F2D8-945C-758E-C5116574D8E7}"/>
+              </a:ext>
+            </a:extLst>
+          </p:cNvPr>
+          <p:cNvSpPr/>
+          <p:nvPr/>
+        </p:nvSpPr>
+        <p:spPr>
+          <a:xfrm>
+            <a:off x="3809103" y="5293646"/>
+            <a:ext cx="1182012" cy="306323"/>
+          </a:xfrm>
+          <a:prstGeom prst="rect">
+            <a:avLst/>
+          </a:prstGeom>
+          <a:noFill/>
+          <a:ln w="0">
+            <a:noFill/>
+          </a:ln>
+        </p:spPr>
+        <p:style>
+          <a:lnRef idx="0">
+            <a:scrgbClr r="0" g="0" b="0"/>
+          </a:lnRef>
+          <a:fillRef idx="0">
+            <a:scrgbClr r="0" g="0" b="0"/>
+          </a:fillRef>
+          <a:effectRef idx="0">
+            <a:scrgbClr r="0" g="0" b="0"/>
+          </a:effectRef>
+          <a:fontRef idx="minor"/>
+        </p:style>
+        <p:txBody>
+          <a:bodyPr wrap="square" lIns="90000" tIns="45000" rIns="90000" bIns="45000" anchor="t">
+            <a:spAutoFit/>
+          </a:bodyPr>
+          <a:lstStyle/>
+          <a:p>
+            <a:pPr algn="ctr"/>
+            <a:r>
+              <a:rPr lang="en-US" sz="1400" spc="-1" dirty="0">
+                <a:solidFill>
+                  <a:srgbClr val="000000"/>
+                </a:solidFill>
+              </a:rPr>
+              <a:t>USB-UART</a:t>
+            </a:r>
+            <a:endParaRPr lang="en-US" sz="1400" b="0" strike="noStrike" spc="-1" dirty="0">
+              <a:solidFill>
+                <a:srgbClr val="000000"/>
+              </a:solidFill>
+              <a:latin typeface="Arial"/>
+            </a:endParaRPr>
+          </a:p>
+        </p:txBody>
+      </p:sp>
+      <p:sp>
+        <p:nvSpPr>
+          <p:cNvPr id="41" name="文字方塊 40">
+            <a:extLst>
+              <a:ext uri="{FF2B5EF4-FFF2-40B4-BE49-F238E27FC236}">
+                <a16:creationId xmlns:a16="http://schemas.microsoft.com/office/drawing/2014/main" id="{10F817FE-BFD2-0EF6-3A08-B7A51E219AAA}"/>
+              </a:ext>
+            </a:extLst>
+          </p:cNvPr>
+          <p:cNvSpPr txBox="1"/>
+          <p:nvPr/>
+        </p:nvSpPr>
+        <p:spPr>
+          <a:xfrm>
+            <a:off x="5863991" y="2025573"/>
+            <a:ext cx="6094428" cy="2862322"/>
+          </a:xfrm>
+          <a:prstGeom prst="rect">
+            <a:avLst/>
+          </a:prstGeom>
+          <a:noFill/>
+        </p:spPr>
+        <p:txBody>
+          <a:bodyPr wrap="square">
+            <a:spAutoFit/>
+          </a:bodyPr>
+          <a:lstStyle/>
+          <a:p>
+            <a:pPr>
+              <a:buNone/>
+            </a:pPr>
+            <a:r>
+              <a:rPr lang="en-US" b="1" dirty="0">
+                <a:latin typeface="Times New Roman" panose="02020603050405020304" pitchFamily="18" charset="0"/>
+                <a:cs typeface="Times New Roman" panose="02020603050405020304" pitchFamily="18" charset="0"/>
+              </a:rPr>
+              <a:t>2 × AXI UART 16550 Instances:</a:t>
+            </a:r>
+            <a:endParaRPr lang="en-US" dirty="0">
+              <a:latin typeface="Times New Roman" panose="02020603050405020304" pitchFamily="18" charset="0"/>
+              <a:cs typeface="Times New Roman" panose="02020603050405020304" pitchFamily="18" charset="0"/>
+            </a:endParaRPr>
+          </a:p>
+          <a:p>
+            <a:pPr>
+              <a:buNone/>
+            </a:pPr>
+            <a:endParaRPr lang="en-US" b="1" dirty="0">
+              <a:latin typeface="Times New Roman" panose="02020603050405020304" pitchFamily="18" charset="0"/>
+              <a:cs typeface="Times New Roman" panose="02020603050405020304" pitchFamily="18" charset="0"/>
+            </a:endParaRPr>
+          </a:p>
+          <a:p>
+            <a:pPr>
+              <a:buNone/>
+            </a:pPr>
+            <a:r>
+              <a:rPr lang="en-US" b="1" dirty="0">
+                <a:latin typeface="Times New Roman" panose="02020603050405020304" pitchFamily="18" charset="0"/>
+                <a:cs typeface="Times New Roman" panose="02020603050405020304" pitchFamily="18" charset="0"/>
+              </a:rPr>
+              <a:t>uart_USB</a:t>
+            </a:r>
+            <a:r>
+              <a:rPr lang="zh-TW" altLang="en-US" b="1" dirty="0">
+                <a:latin typeface="Times New Roman" panose="02020603050405020304" pitchFamily="18" charset="0"/>
+                <a:cs typeface="Times New Roman" panose="02020603050405020304" pitchFamily="18" charset="0"/>
+              </a:rPr>
+              <a:t> </a:t>
+            </a:r>
+            <a:r>
+              <a:rPr lang="en-US" b="1" dirty="0">
+                <a:latin typeface="Times New Roman" panose="02020603050405020304" pitchFamily="18" charset="0"/>
+                <a:cs typeface="Times New Roman" panose="02020603050405020304" pitchFamily="18" charset="0"/>
+              </a:rPr>
+              <a:t>— Console / Debug</a:t>
+            </a:r>
+            <a:endParaRPr lang="en-US" dirty="0">
+              <a:latin typeface="Times New Roman" panose="02020603050405020304" pitchFamily="18" charset="0"/>
+              <a:cs typeface="Times New Roman" panose="02020603050405020304" pitchFamily="18" charset="0"/>
+            </a:endParaRPr>
+          </a:p>
+          <a:p>
+            <a:pPr lvl="1">
+              <a:buFont typeface="Arial" panose="020B0604020202020204" pitchFamily="34" charset="0"/>
+              <a:buChar char="•"/>
+            </a:pPr>
+            <a:r>
+              <a:rPr lang="en-US" dirty="0">
+                <a:latin typeface="Times New Roman" panose="02020603050405020304" pitchFamily="18" charset="0"/>
+                <a:cs typeface="Times New Roman" panose="02020603050405020304" pitchFamily="18" charset="0"/>
+              </a:rPr>
+              <a:t>Connected to on-board USB-UART via Micro-USB (J3)</a:t>
+            </a:r>
+          </a:p>
+          <a:p>
+            <a:pPr lvl="1">
+              <a:buFont typeface="Arial" panose="020B0604020202020204" pitchFamily="34" charset="0"/>
+              <a:buChar char="•"/>
+            </a:pPr>
+            <a:r>
+              <a:rPr lang="en-US" dirty="0">
+                <a:latin typeface="Times New Roman" panose="02020603050405020304" pitchFamily="18" charset="0"/>
+                <a:cs typeface="Times New Roman" panose="02020603050405020304" pitchFamily="18" charset="0"/>
+              </a:rPr>
+              <a:t>No DIP pin exposed — accessed through USB cable</a:t>
+            </a:r>
+          </a:p>
+          <a:p>
+            <a:pPr lvl="1">
+              <a:buFont typeface="Arial" panose="020B0604020202020204" pitchFamily="34" charset="0"/>
+              <a:buChar char="•"/>
+            </a:pPr>
+            <a:endParaRPr lang="en-US" dirty="0">
+              <a:latin typeface="Times New Roman" panose="02020603050405020304" pitchFamily="18" charset="0"/>
+              <a:cs typeface="Times New Roman" panose="02020603050405020304" pitchFamily="18" charset="0"/>
+            </a:endParaRPr>
+          </a:p>
+          <a:p>
+            <a:pPr>
+              <a:buNone/>
+            </a:pPr>
+            <a:r>
+              <a:rPr lang="en-US" b="1" dirty="0">
+                <a:latin typeface="Times New Roman" panose="02020603050405020304" pitchFamily="18" charset="0"/>
+                <a:cs typeface="Times New Roman" panose="02020603050405020304" pitchFamily="18" charset="0"/>
+              </a:rPr>
+              <a:t>uart_1 — External Communication</a:t>
+            </a:r>
+            <a:endParaRPr lang="en-US" dirty="0">
+              <a:latin typeface="Times New Roman" panose="02020603050405020304" pitchFamily="18" charset="0"/>
+              <a:cs typeface="Times New Roman" panose="02020603050405020304" pitchFamily="18" charset="0"/>
+            </a:endParaRPr>
+          </a:p>
+          <a:p>
+            <a:pPr lvl="1">
+              <a:buFont typeface="Arial" panose="020B0604020202020204" pitchFamily="34" charset="0"/>
+              <a:buChar char="•"/>
+            </a:pPr>
+            <a:r>
+              <a:rPr lang="en-US" dirty="0">
+                <a:latin typeface="Times New Roman" panose="02020603050405020304" pitchFamily="18" charset="0"/>
+                <a:cs typeface="Times New Roman" panose="02020603050405020304" pitchFamily="18" charset="0"/>
+              </a:rPr>
+              <a:t>TX/RX routed to DIP Pin 11 / Pin 12</a:t>
+            </a:r>
+          </a:p>
+          <a:p>
+            <a:pPr lvl="1">
+              <a:buFont typeface="Arial" panose="020B0604020202020204" pitchFamily="34" charset="0"/>
+              <a:buChar char="•"/>
+            </a:pPr>
+            <a:r>
+              <a:rPr lang="en-US" dirty="0">
+                <a:latin typeface="Times New Roman" panose="02020603050405020304" pitchFamily="18" charset="0"/>
+                <a:cs typeface="Times New Roman" panose="02020603050405020304" pitchFamily="18" charset="0"/>
+              </a:rPr>
+              <a:t>Available for connecting external devices (sensors, modules, another MCU)</a:t>
+            </a:r>
+          </a:p>
+        </p:txBody>
+      </p:sp>
+    </p:spTree>
+    <p:extLst>
+      <p:ext uri="{BB962C8B-B14F-4D97-AF65-F5344CB8AC3E}">
+        <p14:creationId xmlns:p14="http://schemas.microsoft.com/office/powerpoint/2010/main" val="3879458922"/>
+      </p:ext>
+    </p:extLst>
+  </p:cSld>
+  <p:clrMapOvr>
+    <a:masterClrMapping/>
+  </p:clrMapOvr>
+</p:sld>
+</file>
+
+<file path=ppt/slides/slide11.xml><?xml version="1.0" encoding="utf-8"?>
+<p:sld xmlns:a="http://schemas.openxmlformats.org/drawingml/2006/main" xmlns:r="http://schemas.openxmlformats.org/officeDocument/2006/relationships" xmlns:p="http://schemas.openxmlformats.org/presentationml/2006/main">
+  <p:cSld>
+    <p:spTree>
+      <p:nvGrpSpPr>
+        <p:cNvPr id="1" name="">
+          <a:extLst>
+            <a:ext uri="{FF2B5EF4-FFF2-40B4-BE49-F238E27FC236}">
               <a16:creationId xmlns:a16="http://schemas.microsoft.com/office/drawing/2014/main" id="{4F0A9BC7-1AC6-8836-FEB4-E0644C25B981}"/>
             </a:ext>
           </a:extLst>
@@ -10656,7 +11469,7 @@
 </p:sld>
 </file>
 
-<file path=ppt/slides/slide11.xml><?xml version="1.0" encoding="utf-8"?>
+<file path=ppt/slides/slide12.xml><?xml version="1.0" encoding="utf-8"?>
 <p:sld xmlns:a="http://schemas.openxmlformats.org/drawingml/2006/main" xmlns:r="http://schemas.openxmlformats.org/officeDocument/2006/relationships" xmlns:p="http://schemas.openxmlformats.org/presentationml/2006/main">
   <p:cSld>
     <p:spTree>
@@ -11341,7 +12154,7 @@
 </p:sld>
 </file>
 
-<file path=ppt/slides/slide12.xml><?xml version="1.0" encoding="utf-8"?>
+<file path=ppt/slides/slide13.xml><?xml version="1.0" encoding="utf-8"?>
 <p:sld xmlns:a="http://schemas.openxmlformats.org/drawingml/2006/main" xmlns:r="http://schemas.openxmlformats.org/officeDocument/2006/relationships" xmlns:p="http://schemas.openxmlformats.org/presentationml/2006/main">
   <p:cSld>
     <p:spTree>
@@ -13323,7 +14136,7 @@
 </p:sld>
 </file>
 
-<file path=ppt/slides/slide13.xml><?xml version="1.0" encoding="utf-8"?>
+<file path=ppt/slides/slide14.xml><?xml version="1.0" encoding="utf-8"?>
 <p:sld xmlns:a="http://schemas.openxmlformats.org/drawingml/2006/main" xmlns:r="http://schemas.openxmlformats.org/officeDocument/2006/relationships" xmlns:p="http://schemas.openxmlformats.org/presentationml/2006/main">
   <p:cSld>
     <p:spTree>
@@ -13468,7 +14281,7 @@
 </p:sld>
 </file>
 
-<file path=ppt/slides/slide14.xml><?xml version="1.0" encoding="utf-8"?>
+<file path=ppt/slides/slide15.xml><?xml version="1.0" encoding="utf-8"?>
 <p:sld xmlns:a="http://schemas.openxmlformats.org/drawingml/2006/main" xmlns:r="http://schemas.openxmlformats.org/officeDocument/2006/relationships" xmlns:p="http://schemas.openxmlformats.org/presentationml/2006/main">
   <p:cSld>
     <p:spTree>
@@ -13626,7 +14439,7 @@
 </p:sld>
 </file>
 
-<file path=ppt/slides/slide15.xml><?xml version="1.0" encoding="utf-8"?>
+<file path=ppt/slides/slide16.xml><?xml version="1.0" encoding="utf-8"?>
 <p:sld xmlns:a="http://schemas.openxmlformats.org/drawingml/2006/main" xmlns:r="http://schemas.openxmlformats.org/officeDocument/2006/relationships" xmlns:p="http://schemas.openxmlformats.org/presentationml/2006/main">
   <p:cSld>
     <p:spTree>
@@ -13853,7 +14666,7 @@
 </p:sld>
 </file>
 
-<file path=ppt/slides/slide16.xml><?xml version="1.0" encoding="utf-8"?>
+<file path=ppt/slides/slide17.xml><?xml version="1.0" encoding="utf-8"?>
 <p:sld xmlns:a="http://schemas.openxmlformats.org/drawingml/2006/main" xmlns:r="http://schemas.openxmlformats.org/officeDocument/2006/relationships" xmlns:p="http://schemas.openxmlformats.org/presentationml/2006/main">
   <p:cSld>
     <p:spTree>
@@ -13959,7 +14772,7 @@
 </p:sld>
 </file>
 
-<file path=ppt/slides/slide17.xml><?xml version="1.0" encoding="utf-8"?>
+<file path=ppt/slides/slide18.xml><?xml version="1.0" encoding="utf-8"?>
 <p:sld xmlns:a="http://schemas.openxmlformats.org/drawingml/2006/main" xmlns:r="http://schemas.openxmlformats.org/officeDocument/2006/relationships" xmlns:p="http://schemas.openxmlformats.org/presentationml/2006/main">
   <p:cSld>
     <p:spTree>
@@ -14176,7 +14989,7 @@
 </p:sld>
 </file>
 
-<file path=ppt/slides/slide18.xml><?xml version="1.0" encoding="utf-8"?>
+<file path=ppt/slides/slide19.xml><?xml version="1.0" encoding="utf-8"?>
 <p:sld xmlns:a="http://schemas.openxmlformats.org/drawingml/2006/main" xmlns:r="http://schemas.openxmlformats.org/officeDocument/2006/relationships" xmlns:p="http://schemas.openxmlformats.org/presentationml/2006/main">
   <p:cSld>
     <p:spTree>
@@ -14606,7 +15419,305 @@
 </p:sld>
 </file>
 
-<file path=ppt/slides/slide19.xml><?xml version="1.0" encoding="utf-8"?>
+<file path=ppt/slides/slide2.xml><?xml version="1.0" encoding="utf-8"?>
+<p:sld xmlns:a="http://schemas.openxmlformats.org/drawingml/2006/main" xmlns:r="http://schemas.openxmlformats.org/officeDocument/2006/relationships" xmlns:p="http://schemas.openxmlformats.org/presentationml/2006/main">
+  <p:cSld>
+    <p:spTree>
+      <p:nvGrpSpPr>
+        <p:cNvPr id="1" name="">
+          <a:extLst>
+            <a:ext uri="{FF2B5EF4-FFF2-40B4-BE49-F238E27FC236}">
+              <a16:creationId xmlns:a16="http://schemas.microsoft.com/office/drawing/2014/main" id="{6803CB5C-B2D4-60EF-03DA-4102F52F4185}"/>
+            </a:ext>
+          </a:extLst>
+        </p:cNvPr>
+        <p:cNvGrpSpPr/>
+        <p:nvPr/>
+      </p:nvGrpSpPr>
+      <p:grpSpPr>
+        <a:xfrm>
+          <a:off x="0" y="0"/>
+          <a:ext cx="0" cy="0"/>
+          <a:chOff x="0" y="0"/>
+          <a:chExt cx="0" cy="0"/>
+        </a:xfrm>
+      </p:grpSpPr>
+      <p:sp>
+        <p:nvSpPr>
+          <p:cNvPr id="69" name="PlaceHolder 1">
+            <a:extLst>
+              <a:ext uri="{FF2B5EF4-FFF2-40B4-BE49-F238E27FC236}">
+                <a16:creationId xmlns:a16="http://schemas.microsoft.com/office/drawing/2014/main" id="{2D160DEC-BA85-3F13-32B9-B2BD0AAABA1B}"/>
+              </a:ext>
+            </a:extLst>
+          </p:cNvPr>
+          <p:cNvSpPr>
+            <a:spLocks noGrp="1"/>
+          </p:cNvSpPr>
+          <p:nvPr>
+            <p:ph type="title"/>
+          </p:nvPr>
+        </p:nvSpPr>
+        <p:spPr>
+          <a:xfrm>
+            <a:off x="1015920" y="0"/>
+            <a:ext cx="10972080" cy="1142280"/>
+          </a:xfrm>
+          <a:prstGeom prst="rect">
+            <a:avLst/>
+          </a:prstGeom>
+          <a:noFill/>
+          <a:ln w="0">
+            <a:noFill/>
+          </a:ln>
+        </p:spPr>
+        <p:txBody>
+          <a:bodyPr lIns="91440" tIns="45720" rIns="91440" bIns="45720" anchor="ctr">
+            <a:noAutofit/>
+          </a:bodyPr>
+          <a:lstStyle/>
+          <a:p>
+            <a:pPr indent="0">
+              <a:lnSpc>
+                <a:spcPct val="100000"/>
+              </a:lnSpc>
+              <a:buNone/>
+              <a:tabLst>
+                <a:tab pos="0" algn="l"/>
+              </a:tabLst>
+            </a:pPr>
+            <a:r>
+              <a:rPr lang="en-US" altLang="zh-TW" sz="4000" b="1" spc="-1" dirty="0">
+                <a:solidFill>
+                  <a:srgbClr val="DDDDDD"/>
+                </a:solidFill>
+                <a:latin typeface="Calibri"/>
+                <a:ea typeface="Calibri"/>
+              </a:rPr>
+              <a:t>Outline</a:t>
+            </a:r>
+            <a:endParaRPr lang="en-US" sz="4000" b="0" strike="noStrike" spc="-1" dirty="0">
+              <a:solidFill>
+                <a:srgbClr val="000000"/>
+              </a:solidFill>
+              <a:latin typeface="Arial"/>
+            </a:endParaRPr>
+          </a:p>
+        </p:txBody>
+      </p:sp>
+      <p:sp>
+        <p:nvSpPr>
+          <p:cNvPr id="4" name="文字方塊 3">
+            <a:extLst>
+              <a:ext uri="{FF2B5EF4-FFF2-40B4-BE49-F238E27FC236}">
+                <a16:creationId xmlns:a16="http://schemas.microsoft.com/office/drawing/2014/main" id="{C735929A-EEB5-117D-54CD-459EF48CEBA7}"/>
+              </a:ext>
+            </a:extLst>
+          </p:cNvPr>
+          <p:cNvSpPr txBox="1"/>
+          <p:nvPr/>
+        </p:nvSpPr>
+        <p:spPr>
+          <a:xfrm>
+            <a:off x="572575" y="1468582"/>
+            <a:ext cx="11213772" cy="5185522"/>
+          </a:xfrm>
+          <a:prstGeom prst="rect">
+            <a:avLst/>
+          </a:prstGeom>
+          <a:noFill/>
+        </p:spPr>
+        <p:txBody>
+          <a:bodyPr wrap="square" rtlCol="0">
+            <a:spAutoFit/>
+          </a:bodyPr>
+          <a:lstStyle/>
+          <a:p>
+            <a:pPr marL="285750" indent="-285750">
+              <a:lnSpc>
+                <a:spcPct val="150000"/>
+              </a:lnSpc>
+              <a:buFont typeface="Arial" panose="020B0604020202020204" pitchFamily="34" charset="0"/>
+              <a:buChar char="•"/>
+            </a:pPr>
+            <a:r>
+              <a:rPr lang="en-US" sz="2800" dirty="0">
+                <a:latin typeface="Times New Roman" panose="02020603050405020304" pitchFamily="18" charset="0"/>
+                <a:cs typeface="Times New Roman" panose="02020603050405020304" pitchFamily="18" charset="0"/>
+              </a:rPr>
+              <a:t>Overview Microcontroller</a:t>
+            </a:r>
+          </a:p>
+          <a:p>
+            <a:pPr marL="285750" indent="-285750">
+              <a:lnSpc>
+                <a:spcPct val="150000"/>
+              </a:lnSpc>
+              <a:buFont typeface="Arial" panose="020B0604020202020204" pitchFamily="34" charset="0"/>
+              <a:buChar char="•"/>
+            </a:pPr>
+            <a:r>
+              <a:rPr lang="en-US" sz="2800" dirty="0">
+                <a:latin typeface="Times New Roman" panose="02020603050405020304" pitchFamily="18" charset="0"/>
+                <a:cs typeface="Times New Roman" panose="02020603050405020304" pitchFamily="18" charset="0"/>
+              </a:rPr>
+              <a:t>FPGA Selection and Spec</a:t>
+            </a:r>
+          </a:p>
+          <a:p>
+            <a:pPr marL="285750" indent="-285750">
+              <a:lnSpc>
+                <a:spcPct val="150000"/>
+              </a:lnSpc>
+              <a:buFont typeface="Arial" panose="020B0604020202020204" pitchFamily="34" charset="0"/>
+              <a:buChar char="•"/>
+            </a:pPr>
+            <a:r>
+              <a:rPr lang="en-US" sz="2800" dirty="0">
+                <a:latin typeface="Times New Roman" panose="02020603050405020304" pitchFamily="18" charset="0"/>
+                <a:cs typeface="Times New Roman" panose="02020603050405020304" pitchFamily="18" charset="0"/>
+              </a:rPr>
+              <a:t>GPIO / Interrupt System / </a:t>
+            </a:r>
+            <a:r>
+              <a:rPr lang="zh-TW" altLang="en-US" sz="2800" dirty="0">
+                <a:latin typeface="Times New Roman" panose="02020603050405020304" pitchFamily="18" charset="0"/>
+                <a:cs typeface="Times New Roman" panose="02020603050405020304" pitchFamily="18" charset="0"/>
+              </a:rPr>
+              <a:t> </a:t>
+            </a:r>
+            <a:r>
+              <a:rPr lang="en-US" altLang="zh-TW" sz="2800" dirty="0">
+                <a:latin typeface="Times New Roman" panose="02020603050405020304" pitchFamily="18" charset="0"/>
+                <a:cs typeface="Times New Roman" panose="02020603050405020304" pitchFamily="18" charset="0"/>
+              </a:rPr>
+              <a:t>Timer &amp; PWM / XADC / UART</a:t>
+            </a:r>
+          </a:p>
+          <a:p>
+            <a:pPr marL="285750" indent="-285750">
+              <a:lnSpc>
+                <a:spcPct val="150000"/>
+              </a:lnSpc>
+              <a:buFont typeface="Arial" panose="020B0604020202020204" pitchFamily="34" charset="0"/>
+              <a:buChar char="•"/>
+            </a:pPr>
+            <a:r>
+              <a:rPr lang="en-US" sz="2800" dirty="0">
+                <a:solidFill>
+                  <a:srgbClr val="FF0000"/>
+                </a:solidFill>
+                <a:latin typeface="Times New Roman" panose="02020603050405020304" pitchFamily="18" charset="0"/>
+                <a:cs typeface="Times New Roman" panose="02020603050405020304" pitchFamily="18" charset="0"/>
+              </a:rPr>
+              <a:t>Memory Hierarchy</a:t>
+            </a:r>
+          </a:p>
+          <a:p>
+            <a:pPr marL="285750" indent="-285750">
+              <a:lnSpc>
+                <a:spcPct val="150000"/>
+              </a:lnSpc>
+              <a:buFont typeface="Arial" panose="020B0604020202020204" pitchFamily="34" charset="0"/>
+              <a:buChar char="•"/>
+            </a:pPr>
+            <a:r>
+              <a:rPr lang="en-US" altLang="zh-TW" sz="2800" dirty="0">
+                <a:latin typeface="Times New Roman" panose="02020603050405020304" pitchFamily="18" charset="0"/>
+                <a:cs typeface="Times New Roman" panose="02020603050405020304" pitchFamily="18" charset="0"/>
+              </a:rPr>
+              <a:t>IP</a:t>
+            </a:r>
+            <a:r>
+              <a:rPr lang="zh-TW" altLang="en-US" sz="2800" dirty="0">
+                <a:latin typeface="Times New Roman" panose="02020603050405020304" pitchFamily="18" charset="0"/>
+                <a:cs typeface="Times New Roman" panose="02020603050405020304" pitchFamily="18" charset="0"/>
+              </a:rPr>
+              <a:t> </a:t>
+            </a:r>
+            <a:r>
+              <a:rPr lang="en-US" altLang="zh-TW" sz="2800" dirty="0">
+                <a:latin typeface="Times New Roman" panose="02020603050405020304" pitchFamily="18" charset="0"/>
+                <a:cs typeface="Times New Roman" panose="02020603050405020304" pitchFamily="18" charset="0"/>
+              </a:rPr>
+              <a:t>Memory Mapped</a:t>
+            </a:r>
+            <a:endParaRPr lang="en-US" sz="2800" dirty="0">
+              <a:latin typeface="Times New Roman" panose="02020603050405020304" pitchFamily="18" charset="0"/>
+              <a:cs typeface="Times New Roman" panose="02020603050405020304" pitchFamily="18" charset="0"/>
+            </a:endParaRPr>
+          </a:p>
+          <a:p>
+            <a:pPr marL="285750" indent="-285750">
+              <a:lnSpc>
+                <a:spcPct val="150000"/>
+              </a:lnSpc>
+              <a:buFont typeface="Arial" panose="020B0604020202020204" pitchFamily="34" charset="0"/>
+              <a:buChar char="•"/>
+            </a:pPr>
+            <a:r>
+              <a:rPr lang="en-US" altLang="zh-TW" sz="2800" dirty="0">
+                <a:latin typeface="Times New Roman" panose="02020603050405020304" pitchFamily="18" charset="0"/>
+                <a:cs typeface="Times New Roman" panose="02020603050405020304" pitchFamily="18" charset="0"/>
+              </a:rPr>
+              <a:t>Report</a:t>
+            </a:r>
+            <a:endParaRPr lang="en-US" sz="2800" dirty="0">
+              <a:latin typeface="Times New Roman" panose="02020603050405020304" pitchFamily="18" charset="0"/>
+              <a:cs typeface="Times New Roman" panose="02020603050405020304" pitchFamily="18" charset="0"/>
+            </a:endParaRPr>
+          </a:p>
+          <a:p>
+            <a:pPr marL="285750" indent="-285750">
+              <a:lnSpc>
+                <a:spcPct val="150000"/>
+              </a:lnSpc>
+              <a:buFont typeface="Arial" panose="020B0604020202020204" pitchFamily="34" charset="0"/>
+              <a:buChar char="•"/>
+            </a:pPr>
+            <a:r>
+              <a:rPr lang="en-US" sz="2800" dirty="0">
+                <a:latin typeface="Times New Roman" panose="02020603050405020304" pitchFamily="18" charset="0"/>
+                <a:cs typeface="Times New Roman" panose="02020603050405020304" pitchFamily="18" charset="0"/>
+              </a:rPr>
+              <a:t>Software Design Flow</a:t>
+            </a:r>
+          </a:p>
+          <a:p>
+            <a:pPr marL="285750" indent="-285750">
+              <a:lnSpc>
+                <a:spcPct val="150000"/>
+              </a:lnSpc>
+              <a:buFont typeface="Arial" panose="020B0604020202020204" pitchFamily="34" charset="0"/>
+              <a:buChar char="•"/>
+            </a:pPr>
+            <a:r>
+              <a:rPr lang="en-US" sz="2800" dirty="0">
+                <a:solidFill>
+                  <a:srgbClr val="FF0000"/>
+                </a:solidFill>
+                <a:latin typeface="Times New Roman" panose="02020603050405020304" pitchFamily="18" charset="0"/>
+                <a:cs typeface="Times New Roman" panose="02020603050405020304" pitchFamily="18" charset="0"/>
+              </a:rPr>
+              <a:t>Standalone Boot Sequence</a:t>
+            </a:r>
+          </a:p>
+        </p:txBody>
+      </p:sp>
+    </p:spTree>
+    <p:extLst>
+      <p:ext uri="{BB962C8B-B14F-4D97-AF65-F5344CB8AC3E}">
+        <p14:creationId xmlns:p14="http://schemas.microsoft.com/office/powerpoint/2010/main" val="1176634423"/>
+      </p:ext>
+    </p:extLst>
+  </p:cSld>
+  <p:clrMapOvr>
+    <a:masterClrMapping/>
+  </p:clrMapOvr>
+</p:sld>
+</file>
+
+<file path=ppt/slides/slide20.xml><?xml version="1.0" encoding="utf-8"?>
 <p:sld xmlns:a="http://schemas.openxmlformats.org/drawingml/2006/main" xmlns:r="http://schemas.openxmlformats.org/officeDocument/2006/relationships" xmlns:p="http://schemas.openxmlformats.org/presentationml/2006/main">
   <p:cSld>
     <p:spTree>
@@ -14908,305 +16019,7 @@
 </p:sld>
 </file>
 
-<file path=ppt/slides/slide2.xml><?xml version="1.0" encoding="utf-8"?>
-<p:sld xmlns:a="http://schemas.openxmlformats.org/drawingml/2006/main" xmlns:r="http://schemas.openxmlformats.org/officeDocument/2006/relationships" xmlns:p="http://schemas.openxmlformats.org/presentationml/2006/main">
-  <p:cSld>
-    <p:spTree>
-      <p:nvGrpSpPr>
-        <p:cNvPr id="1" name="">
-          <a:extLst>
-            <a:ext uri="{FF2B5EF4-FFF2-40B4-BE49-F238E27FC236}">
-              <a16:creationId xmlns:a16="http://schemas.microsoft.com/office/drawing/2014/main" id="{6803CB5C-B2D4-60EF-03DA-4102F52F4185}"/>
-            </a:ext>
-          </a:extLst>
-        </p:cNvPr>
-        <p:cNvGrpSpPr/>
-        <p:nvPr/>
-      </p:nvGrpSpPr>
-      <p:grpSpPr>
-        <a:xfrm>
-          <a:off x="0" y="0"/>
-          <a:ext cx="0" cy="0"/>
-          <a:chOff x="0" y="0"/>
-          <a:chExt cx="0" cy="0"/>
-        </a:xfrm>
-      </p:grpSpPr>
-      <p:sp>
-        <p:nvSpPr>
-          <p:cNvPr id="69" name="PlaceHolder 1">
-            <a:extLst>
-              <a:ext uri="{FF2B5EF4-FFF2-40B4-BE49-F238E27FC236}">
-                <a16:creationId xmlns:a16="http://schemas.microsoft.com/office/drawing/2014/main" id="{2D160DEC-BA85-3F13-32B9-B2BD0AAABA1B}"/>
-              </a:ext>
-            </a:extLst>
-          </p:cNvPr>
-          <p:cNvSpPr>
-            <a:spLocks noGrp="1"/>
-          </p:cNvSpPr>
-          <p:nvPr>
-            <p:ph type="title"/>
-          </p:nvPr>
-        </p:nvSpPr>
-        <p:spPr>
-          <a:xfrm>
-            <a:off x="1015920" y="0"/>
-            <a:ext cx="10972080" cy="1142280"/>
-          </a:xfrm>
-          <a:prstGeom prst="rect">
-            <a:avLst/>
-          </a:prstGeom>
-          <a:noFill/>
-          <a:ln w="0">
-            <a:noFill/>
-          </a:ln>
-        </p:spPr>
-        <p:txBody>
-          <a:bodyPr lIns="91440" tIns="45720" rIns="91440" bIns="45720" anchor="ctr">
-            <a:noAutofit/>
-          </a:bodyPr>
-          <a:lstStyle/>
-          <a:p>
-            <a:pPr indent="0">
-              <a:lnSpc>
-                <a:spcPct val="100000"/>
-              </a:lnSpc>
-              <a:buNone/>
-              <a:tabLst>
-                <a:tab pos="0" algn="l"/>
-              </a:tabLst>
-            </a:pPr>
-            <a:r>
-              <a:rPr lang="en-US" altLang="zh-TW" sz="4000" b="1" spc="-1" dirty="0">
-                <a:solidFill>
-                  <a:srgbClr val="DDDDDD"/>
-                </a:solidFill>
-                <a:latin typeface="Calibri"/>
-                <a:ea typeface="Calibri"/>
-              </a:rPr>
-              <a:t>Outline</a:t>
-            </a:r>
-            <a:endParaRPr lang="en-US" sz="4000" b="0" strike="noStrike" spc="-1" dirty="0">
-              <a:solidFill>
-                <a:srgbClr val="000000"/>
-              </a:solidFill>
-              <a:latin typeface="Arial"/>
-            </a:endParaRPr>
-          </a:p>
-        </p:txBody>
-      </p:sp>
-      <p:sp>
-        <p:nvSpPr>
-          <p:cNvPr id="4" name="文字方塊 3">
-            <a:extLst>
-              <a:ext uri="{FF2B5EF4-FFF2-40B4-BE49-F238E27FC236}">
-                <a16:creationId xmlns:a16="http://schemas.microsoft.com/office/drawing/2014/main" id="{C735929A-EEB5-117D-54CD-459EF48CEBA7}"/>
-              </a:ext>
-            </a:extLst>
-          </p:cNvPr>
-          <p:cNvSpPr txBox="1"/>
-          <p:nvPr/>
-        </p:nvSpPr>
-        <p:spPr>
-          <a:xfrm>
-            <a:off x="572575" y="1468582"/>
-            <a:ext cx="11213772" cy="5185522"/>
-          </a:xfrm>
-          <a:prstGeom prst="rect">
-            <a:avLst/>
-          </a:prstGeom>
-          <a:noFill/>
-        </p:spPr>
-        <p:txBody>
-          <a:bodyPr wrap="square" rtlCol="0">
-            <a:spAutoFit/>
-          </a:bodyPr>
-          <a:lstStyle/>
-          <a:p>
-            <a:pPr marL="285750" indent="-285750">
-              <a:lnSpc>
-                <a:spcPct val="150000"/>
-              </a:lnSpc>
-              <a:buFont typeface="Arial" panose="020B0604020202020204" pitchFamily="34" charset="0"/>
-              <a:buChar char="•"/>
-            </a:pPr>
-            <a:r>
-              <a:rPr lang="en-US" sz="2800" dirty="0">
-                <a:latin typeface="Times New Roman" panose="02020603050405020304" pitchFamily="18" charset="0"/>
-                <a:cs typeface="Times New Roman" panose="02020603050405020304" pitchFamily="18" charset="0"/>
-              </a:rPr>
-              <a:t>Overview Microcontroller</a:t>
-            </a:r>
-          </a:p>
-          <a:p>
-            <a:pPr marL="285750" indent="-285750">
-              <a:lnSpc>
-                <a:spcPct val="150000"/>
-              </a:lnSpc>
-              <a:buFont typeface="Arial" panose="020B0604020202020204" pitchFamily="34" charset="0"/>
-              <a:buChar char="•"/>
-            </a:pPr>
-            <a:r>
-              <a:rPr lang="en-US" sz="2800" dirty="0">
-                <a:latin typeface="Times New Roman" panose="02020603050405020304" pitchFamily="18" charset="0"/>
-                <a:cs typeface="Times New Roman" panose="02020603050405020304" pitchFamily="18" charset="0"/>
-              </a:rPr>
-              <a:t>FPGA Selection and Spec</a:t>
-            </a:r>
-          </a:p>
-          <a:p>
-            <a:pPr marL="285750" indent="-285750">
-              <a:lnSpc>
-                <a:spcPct val="150000"/>
-              </a:lnSpc>
-              <a:buFont typeface="Arial" panose="020B0604020202020204" pitchFamily="34" charset="0"/>
-              <a:buChar char="•"/>
-            </a:pPr>
-            <a:r>
-              <a:rPr lang="en-US" sz="2800" dirty="0">
-                <a:latin typeface="Times New Roman" panose="02020603050405020304" pitchFamily="18" charset="0"/>
-                <a:cs typeface="Times New Roman" panose="02020603050405020304" pitchFamily="18" charset="0"/>
-              </a:rPr>
-              <a:t>GPIO / Interrupt System / </a:t>
-            </a:r>
-            <a:r>
-              <a:rPr lang="zh-TW" altLang="en-US" sz="2800" dirty="0">
-                <a:latin typeface="Times New Roman" panose="02020603050405020304" pitchFamily="18" charset="0"/>
-                <a:cs typeface="Times New Roman" panose="02020603050405020304" pitchFamily="18" charset="0"/>
-              </a:rPr>
-              <a:t> </a:t>
-            </a:r>
-            <a:r>
-              <a:rPr lang="en-US" altLang="zh-TW" sz="2800" dirty="0">
-                <a:latin typeface="Times New Roman" panose="02020603050405020304" pitchFamily="18" charset="0"/>
-                <a:cs typeface="Times New Roman" panose="02020603050405020304" pitchFamily="18" charset="0"/>
-              </a:rPr>
-              <a:t>Timer &amp; PWM / XADC / UART</a:t>
-            </a:r>
-          </a:p>
-          <a:p>
-            <a:pPr marL="285750" indent="-285750">
-              <a:lnSpc>
-                <a:spcPct val="150000"/>
-              </a:lnSpc>
-              <a:buFont typeface="Arial" panose="020B0604020202020204" pitchFamily="34" charset="0"/>
-              <a:buChar char="•"/>
-            </a:pPr>
-            <a:r>
-              <a:rPr lang="en-US" sz="2800" dirty="0">
-                <a:solidFill>
-                  <a:srgbClr val="FF0000"/>
-                </a:solidFill>
-                <a:latin typeface="Times New Roman" panose="02020603050405020304" pitchFamily="18" charset="0"/>
-                <a:cs typeface="Times New Roman" panose="02020603050405020304" pitchFamily="18" charset="0"/>
-              </a:rPr>
-              <a:t>Memory Hierarchy</a:t>
-            </a:r>
-          </a:p>
-          <a:p>
-            <a:pPr marL="285750" indent="-285750">
-              <a:lnSpc>
-                <a:spcPct val="150000"/>
-              </a:lnSpc>
-              <a:buFont typeface="Arial" panose="020B0604020202020204" pitchFamily="34" charset="0"/>
-              <a:buChar char="•"/>
-            </a:pPr>
-            <a:r>
-              <a:rPr lang="en-US" altLang="zh-TW" sz="2800" dirty="0">
-                <a:latin typeface="Times New Roman" panose="02020603050405020304" pitchFamily="18" charset="0"/>
-                <a:cs typeface="Times New Roman" panose="02020603050405020304" pitchFamily="18" charset="0"/>
-              </a:rPr>
-              <a:t>IP</a:t>
-            </a:r>
-            <a:r>
-              <a:rPr lang="zh-TW" altLang="en-US" sz="2800" dirty="0">
-                <a:latin typeface="Times New Roman" panose="02020603050405020304" pitchFamily="18" charset="0"/>
-                <a:cs typeface="Times New Roman" panose="02020603050405020304" pitchFamily="18" charset="0"/>
-              </a:rPr>
-              <a:t> </a:t>
-            </a:r>
-            <a:r>
-              <a:rPr lang="en-US" altLang="zh-TW" sz="2800" dirty="0">
-                <a:latin typeface="Times New Roman" panose="02020603050405020304" pitchFamily="18" charset="0"/>
-                <a:cs typeface="Times New Roman" panose="02020603050405020304" pitchFamily="18" charset="0"/>
-              </a:rPr>
-              <a:t>Memory Mapped</a:t>
-            </a:r>
-            <a:endParaRPr lang="en-US" sz="2800" dirty="0">
-              <a:latin typeface="Times New Roman" panose="02020603050405020304" pitchFamily="18" charset="0"/>
-              <a:cs typeface="Times New Roman" panose="02020603050405020304" pitchFamily="18" charset="0"/>
-            </a:endParaRPr>
-          </a:p>
-          <a:p>
-            <a:pPr marL="285750" indent="-285750">
-              <a:lnSpc>
-                <a:spcPct val="150000"/>
-              </a:lnSpc>
-              <a:buFont typeface="Arial" panose="020B0604020202020204" pitchFamily="34" charset="0"/>
-              <a:buChar char="•"/>
-            </a:pPr>
-            <a:r>
-              <a:rPr lang="en-US" altLang="zh-TW" sz="2800" dirty="0">
-                <a:latin typeface="Times New Roman" panose="02020603050405020304" pitchFamily="18" charset="0"/>
-                <a:cs typeface="Times New Roman" panose="02020603050405020304" pitchFamily="18" charset="0"/>
-              </a:rPr>
-              <a:t>Report</a:t>
-            </a:r>
-            <a:endParaRPr lang="en-US" sz="2800" dirty="0">
-              <a:latin typeface="Times New Roman" panose="02020603050405020304" pitchFamily="18" charset="0"/>
-              <a:cs typeface="Times New Roman" panose="02020603050405020304" pitchFamily="18" charset="0"/>
-            </a:endParaRPr>
-          </a:p>
-          <a:p>
-            <a:pPr marL="285750" indent="-285750">
-              <a:lnSpc>
-                <a:spcPct val="150000"/>
-              </a:lnSpc>
-              <a:buFont typeface="Arial" panose="020B0604020202020204" pitchFamily="34" charset="0"/>
-              <a:buChar char="•"/>
-            </a:pPr>
-            <a:r>
-              <a:rPr lang="en-US" sz="2800" dirty="0">
-                <a:latin typeface="Times New Roman" panose="02020603050405020304" pitchFamily="18" charset="0"/>
-                <a:cs typeface="Times New Roman" panose="02020603050405020304" pitchFamily="18" charset="0"/>
-              </a:rPr>
-              <a:t>Software Design Flow</a:t>
-            </a:r>
-          </a:p>
-          <a:p>
-            <a:pPr marL="285750" indent="-285750">
-              <a:lnSpc>
-                <a:spcPct val="150000"/>
-              </a:lnSpc>
-              <a:buFont typeface="Arial" panose="020B0604020202020204" pitchFamily="34" charset="0"/>
-              <a:buChar char="•"/>
-            </a:pPr>
-            <a:r>
-              <a:rPr lang="en-US" sz="2800" dirty="0">
-                <a:solidFill>
-                  <a:srgbClr val="FF0000"/>
-                </a:solidFill>
-                <a:latin typeface="Times New Roman" panose="02020603050405020304" pitchFamily="18" charset="0"/>
-                <a:cs typeface="Times New Roman" panose="02020603050405020304" pitchFamily="18" charset="0"/>
-              </a:rPr>
-              <a:t>Standalone Boot Sequence</a:t>
-            </a:r>
-          </a:p>
-        </p:txBody>
-      </p:sp>
-    </p:spTree>
-    <p:extLst>
-      <p:ext uri="{BB962C8B-B14F-4D97-AF65-F5344CB8AC3E}">
-        <p14:creationId xmlns:p14="http://schemas.microsoft.com/office/powerpoint/2010/main" val="1176634423"/>
-      </p:ext>
-    </p:extLst>
-  </p:cSld>
-  <p:clrMapOvr>
-    <a:masterClrMapping/>
-  </p:clrMapOvr>
-</p:sld>
-</file>
-
-<file path=ppt/slides/slide20.xml><?xml version="1.0" encoding="utf-8"?>
+<file path=ppt/slides/slide21.xml><?xml version="1.0" encoding="utf-8"?>
 <p:sld xmlns:a="http://schemas.openxmlformats.org/drawingml/2006/main" xmlns:r="http://schemas.openxmlformats.org/officeDocument/2006/relationships" xmlns:p="http://schemas.openxmlformats.org/presentationml/2006/main">
   <p:cSld>
     <p:spTree>
@@ -15387,7 +16200,7 @@
 </p:sld>
 </file>
 
-<file path=ppt/slides/slide21.xml><?xml version="1.0" encoding="utf-8"?>
+<file path=ppt/slides/slide22.xml><?xml version="1.0" encoding="utf-8"?>
 <p:sld xmlns:a="http://schemas.openxmlformats.org/drawingml/2006/main" xmlns:r="http://schemas.openxmlformats.org/officeDocument/2006/relationships" xmlns:p="http://schemas.openxmlformats.org/presentationml/2006/main">
   <p:cSld>
     <p:spTree>
@@ -20592,6 +21405,425 @@
         <p:cNvPr id="1" name="">
           <a:extLst>
             <a:ext uri="{FF2B5EF4-FFF2-40B4-BE49-F238E27FC236}">
+              <a16:creationId xmlns:a16="http://schemas.microsoft.com/office/drawing/2014/main" id="{FBA9544B-35C9-B391-3360-F351F557DF73}"/>
+            </a:ext>
+          </a:extLst>
+        </p:cNvPr>
+        <p:cNvGrpSpPr/>
+        <p:nvPr/>
+      </p:nvGrpSpPr>
+      <p:grpSpPr>
+        <a:xfrm>
+          <a:off x="0" y="0"/>
+          <a:ext cx="0" cy="0"/>
+          <a:chOff x="0" y="0"/>
+          <a:chExt cx="0" cy="0"/>
+        </a:xfrm>
+      </p:grpSpPr>
+      <p:sp>
+        <p:nvSpPr>
+          <p:cNvPr id="69" name="PlaceHolder 1">
+            <a:extLst>
+              <a:ext uri="{FF2B5EF4-FFF2-40B4-BE49-F238E27FC236}">
+                <a16:creationId xmlns:a16="http://schemas.microsoft.com/office/drawing/2014/main" id="{5BC7E671-DF55-A170-04FB-150D0A8645AC}"/>
+              </a:ext>
+            </a:extLst>
+          </p:cNvPr>
+          <p:cNvSpPr>
+            <a:spLocks noGrp="1"/>
+          </p:cNvSpPr>
+          <p:nvPr>
+            <p:ph type="title"/>
+          </p:nvPr>
+        </p:nvSpPr>
+        <p:spPr>
+          <a:xfrm>
+            <a:off x="1015920" y="0"/>
+            <a:ext cx="10972080" cy="1142280"/>
+          </a:xfrm>
+          <a:prstGeom prst="rect">
+            <a:avLst/>
+          </a:prstGeom>
+          <a:noFill/>
+          <a:ln w="0">
+            <a:noFill/>
+          </a:ln>
+        </p:spPr>
+        <p:txBody>
+          <a:bodyPr lIns="91440" tIns="45720" rIns="91440" bIns="45720" anchor="ctr">
+            <a:noAutofit/>
+          </a:bodyPr>
+          <a:lstStyle/>
+          <a:p>
+            <a:pPr indent="0">
+              <a:lnSpc>
+                <a:spcPct val="100000"/>
+              </a:lnSpc>
+              <a:buNone/>
+              <a:tabLst>
+                <a:tab pos="0" algn="l"/>
+              </a:tabLst>
+            </a:pPr>
+            <a:r>
+              <a:rPr lang="en-US" altLang="zh-TW" sz="4000" b="1" spc="-1" dirty="0">
+                <a:solidFill>
+                  <a:srgbClr val="DDDDDD"/>
+                </a:solidFill>
+                <a:latin typeface="Calibri"/>
+                <a:ea typeface="Calibri"/>
+              </a:rPr>
+              <a:t>Overview</a:t>
+            </a:r>
+            <a:r>
+              <a:rPr lang="en-US" sz="4000" b="1" strike="noStrike" spc="-1" dirty="0">
+                <a:solidFill>
+                  <a:srgbClr val="DDDDDD"/>
+                </a:solidFill>
+                <a:latin typeface="Calibri"/>
+                <a:ea typeface="Calibri"/>
+              </a:rPr>
+              <a:t> Microcontroller</a:t>
+            </a:r>
+            <a:endParaRPr lang="en-US" sz="4000" b="0" strike="noStrike" spc="-1" dirty="0">
+              <a:solidFill>
+                <a:srgbClr val="000000"/>
+              </a:solidFill>
+              <a:latin typeface="Arial"/>
+            </a:endParaRPr>
+          </a:p>
+        </p:txBody>
+      </p:sp>
+      <p:sp>
+        <p:nvSpPr>
+          <p:cNvPr id="25" name="文字方塊 24">
+            <a:extLst>
+              <a:ext uri="{FF2B5EF4-FFF2-40B4-BE49-F238E27FC236}">
+                <a16:creationId xmlns:a16="http://schemas.microsoft.com/office/drawing/2014/main" id="{81755C5B-BC04-87BB-5F45-E5591ED74F4B}"/>
+              </a:ext>
+            </a:extLst>
+          </p:cNvPr>
+          <p:cNvSpPr txBox="1"/>
+          <p:nvPr/>
+        </p:nvSpPr>
+        <p:spPr>
+          <a:xfrm>
+            <a:off x="676555" y="1749465"/>
+            <a:ext cx="7892410" cy="3693319"/>
+          </a:xfrm>
+          <a:prstGeom prst="rect">
+            <a:avLst/>
+          </a:prstGeom>
+          <a:noFill/>
+        </p:spPr>
+        <p:txBody>
+          <a:bodyPr wrap="square" rtlCol="0">
+            <a:spAutoFit/>
+          </a:bodyPr>
+          <a:lstStyle/>
+          <a:p>
+            <a:pPr marL="285750" indent="-285750">
+              <a:buFont typeface="Arial" panose="020B0604020202020204" pitchFamily="34" charset="0"/>
+              <a:buChar char="•"/>
+            </a:pPr>
+            <a:r>
+              <a:rPr lang="en-US" b="1" dirty="0">
+                <a:solidFill>
+                  <a:srgbClr val="000000"/>
+                </a:solidFill>
+                <a:latin typeface="Times New Roman" panose="02020603050405020304" pitchFamily="18" charset="0"/>
+                <a:cs typeface="Times New Roman" panose="02020603050405020304" pitchFamily="18" charset="0"/>
+              </a:rPr>
+              <a:t>Processor: </a:t>
+            </a:r>
+            <a:r>
+              <a:rPr lang="en-US" dirty="0" err="1">
+                <a:solidFill>
+                  <a:srgbClr val="000000"/>
+                </a:solidFill>
+                <a:latin typeface="Times New Roman" panose="02020603050405020304" pitchFamily="18" charset="0"/>
+                <a:cs typeface="Times New Roman" panose="02020603050405020304" pitchFamily="18" charset="0"/>
+              </a:rPr>
+              <a:t>MicroBlaze</a:t>
+            </a:r>
+            <a:r>
+              <a:rPr lang="en-US" dirty="0">
+                <a:solidFill>
+                  <a:srgbClr val="000000"/>
+                </a:solidFill>
+                <a:latin typeface="Times New Roman" panose="02020603050405020304" pitchFamily="18" charset="0"/>
+                <a:cs typeface="Times New Roman" panose="02020603050405020304" pitchFamily="18" charset="0"/>
+              </a:rPr>
+              <a:t> RISC-V, 32-bit, Single Core</a:t>
+            </a:r>
+          </a:p>
+          <a:p>
+            <a:pPr marL="285750" indent="-285750">
+              <a:buFont typeface="Arial" panose="020B0604020202020204" pitchFamily="34" charset="0"/>
+              <a:buChar char="•"/>
+            </a:pPr>
+            <a:endParaRPr lang="en-US" dirty="0">
+              <a:solidFill>
+                <a:srgbClr val="000000"/>
+              </a:solidFill>
+              <a:latin typeface="Times New Roman" panose="02020603050405020304" pitchFamily="18" charset="0"/>
+              <a:cs typeface="Times New Roman" panose="02020603050405020304" pitchFamily="18" charset="0"/>
+            </a:endParaRPr>
+          </a:p>
+          <a:p>
+            <a:pPr marL="285750" indent="-285750">
+              <a:buFont typeface="Arial" panose="020B0604020202020204" pitchFamily="34" charset="0"/>
+              <a:buChar char="•"/>
+            </a:pPr>
+            <a:r>
+              <a:rPr lang="en-US" b="1" dirty="0">
+                <a:solidFill>
+                  <a:srgbClr val="000000"/>
+                </a:solidFill>
+                <a:latin typeface="Times New Roman" panose="02020603050405020304" pitchFamily="18" charset="0"/>
+                <a:cs typeface="Times New Roman" panose="02020603050405020304" pitchFamily="18" charset="0"/>
+              </a:rPr>
+              <a:t>Clock: </a:t>
+            </a:r>
+            <a:r>
+              <a:rPr lang="en-US" dirty="0">
+                <a:solidFill>
+                  <a:srgbClr val="000000"/>
+                </a:solidFill>
+                <a:latin typeface="Times New Roman" panose="02020603050405020304" pitchFamily="18" charset="0"/>
+                <a:cs typeface="Times New Roman" panose="02020603050405020304" pitchFamily="18" charset="0"/>
+              </a:rPr>
+              <a:t>100 MHz (12 MHz OSC → Clocking Wizard PLL)</a:t>
+            </a:r>
+          </a:p>
+          <a:p>
+            <a:pPr marL="285750" indent="-285750">
+              <a:buFont typeface="Arial" panose="020B0604020202020204" pitchFamily="34" charset="0"/>
+              <a:buChar char="•"/>
+            </a:pPr>
+            <a:endParaRPr lang="en-US" dirty="0">
+              <a:solidFill>
+                <a:srgbClr val="000000"/>
+              </a:solidFill>
+              <a:latin typeface="Times New Roman" panose="02020603050405020304" pitchFamily="18" charset="0"/>
+              <a:cs typeface="Times New Roman" panose="02020603050405020304" pitchFamily="18" charset="0"/>
+            </a:endParaRPr>
+          </a:p>
+          <a:p>
+            <a:pPr marL="285750" indent="-285750">
+              <a:buFont typeface="Arial" panose="020B0604020202020204" pitchFamily="34" charset="0"/>
+              <a:buChar char="•"/>
+            </a:pPr>
+            <a:r>
+              <a:rPr lang="en-US" b="1" dirty="0">
+                <a:solidFill>
+                  <a:srgbClr val="000000"/>
+                </a:solidFill>
+                <a:latin typeface="Times New Roman" panose="02020603050405020304" pitchFamily="18" charset="0"/>
+                <a:cs typeface="Times New Roman" panose="02020603050405020304" pitchFamily="18" charset="0"/>
+              </a:rPr>
+              <a:t>ISA Extensions: RV32IM_Zba_Zbb_Zbc_Zbs</a:t>
+            </a:r>
+          </a:p>
+          <a:p>
+            <a:pPr marL="285750" indent="-285750">
+              <a:buFont typeface="Arial" panose="020B0604020202020204" pitchFamily="34" charset="0"/>
+              <a:buChar char="•"/>
+            </a:pPr>
+            <a:endParaRPr lang="en-US" dirty="0">
+              <a:solidFill>
+                <a:srgbClr val="000000"/>
+              </a:solidFill>
+              <a:latin typeface="Times New Roman" panose="02020603050405020304" pitchFamily="18" charset="0"/>
+              <a:cs typeface="Times New Roman" panose="02020603050405020304" pitchFamily="18" charset="0"/>
+            </a:endParaRPr>
+          </a:p>
+          <a:p>
+            <a:pPr marL="285750" indent="-285750">
+              <a:buFont typeface="Arial" panose="020B0604020202020204" pitchFamily="34" charset="0"/>
+              <a:buChar char="•"/>
+            </a:pPr>
+            <a:r>
+              <a:rPr lang="en-US" b="1" dirty="0">
+                <a:solidFill>
+                  <a:srgbClr val="000000"/>
+                </a:solidFill>
+                <a:latin typeface="Times New Roman" panose="02020603050405020304" pitchFamily="18" charset="0"/>
+                <a:cs typeface="Times New Roman" panose="02020603050405020304" pitchFamily="18" charset="0"/>
+              </a:rPr>
+              <a:t>Local Memory: </a:t>
+            </a:r>
+            <a:r>
+              <a:rPr lang="en-US" dirty="0">
+                <a:solidFill>
+                  <a:srgbClr val="000000"/>
+                </a:solidFill>
+                <a:latin typeface="Times New Roman" panose="02020603050405020304" pitchFamily="18" charset="0"/>
+                <a:cs typeface="Times New Roman" panose="02020603050405020304" pitchFamily="18" charset="0"/>
+              </a:rPr>
+              <a:t>128 KB BRAM (ILMB + DLMB)</a:t>
+            </a:r>
+          </a:p>
+          <a:p>
+            <a:pPr marL="285750" indent="-285750">
+              <a:buFont typeface="Arial" panose="020B0604020202020204" pitchFamily="34" charset="0"/>
+              <a:buChar char="•"/>
+            </a:pPr>
+            <a:endParaRPr lang="en-US" dirty="0">
+              <a:latin typeface="Times New Roman" panose="02020603050405020304" pitchFamily="18" charset="0"/>
+              <a:cs typeface="Times New Roman" panose="02020603050405020304" pitchFamily="18" charset="0"/>
+            </a:endParaRPr>
+          </a:p>
+          <a:p>
+            <a:pPr marL="285750" indent="-285750">
+              <a:buFont typeface="Arial" panose="020B0604020202020204" pitchFamily="34" charset="0"/>
+              <a:buChar char="•"/>
+            </a:pPr>
+            <a:r>
+              <a:rPr lang="en-US" b="1" dirty="0">
+                <a:solidFill>
+                  <a:srgbClr val="000000"/>
+                </a:solidFill>
+                <a:latin typeface="Times New Roman" panose="02020603050405020304" pitchFamily="18" charset="0"/>
+                <a:cs typeface="Times New Roman" panose="02020603050405020304" pitchFamily="18" charset="0"/>
+              </a:rPr>
+              <a:t>Cache: </a:t>
+            </a:r>
+            <a:r>
+              <a:rPr lang="en-US" dirty="0">
+                <a:solidFill>
+                  <a:srgbClr val="FF0000"/>
+                </a:solidFill>
+                <a:latin typeface="Times New Roman" panose="02020603050405020304" pitchFamily="18" charset="0"/>
+                <a:cs typeface="Times New Roman" panose="02020603050405020304" pitchFamily="18" charset="0"/>
+              </a:rPr>
+              <a:t>Disabled</a:t>
+            </a:r>
+            <a:r>
+              <a:rPr lang="en-US" dirty="0">
+                <a:solidFill>
+                  <a:srgbClr val="000000"/>
+                </a:solidFill>
+                <a:latin typeface="Times New Roman" panose="02020603050405020304" pitchFamily="18" charset="0"/>
+                <a:cs typeface="Times New Roman" panose="02020603050405020304" pitchFamily="18" charset="0"/>
+              </a:rPr>
+              <a:t> (I-Cache &amp; D-Cache both off)</a:t>
+            </a:r>
+          </a:p>
+          <a:p>
+            <a:pPr marL="285750" indent="-285750">
+              <a:buFont typeface="Arial" panose="020B0604020202020204" pitchFamily="34" charset="0"/>
+              <a:buChar char="•"/>
+            </a:pPr>
+            <a:endParaRPr lang="en-US" dirty="0">
+              <a:solidFill>
+                <a:srgbClr val="000000"/>
+              </a:solidFill>
+              <a:latin typeface="Times New Roman" panose="02020603050405020304" pitchFamily="18" charset="0"/>
+              <a:cs typeface="Times New Roman" panose="02020603050405020304" pitchFamily="18" charset="0"/>
+            </a:endParaRPr>
+          </a:p>
+          <a:p>
+            <a:pPr marL="285750" indent="-285750">
+              <a:buFont typeface="Arial" panose="020B0604020202020204" pitchFamily="34" charset="0"/>
+              <a:buChar char="•"/>
+            </a:pPr>
+            <a:r>
+              <a:rPr lang="en-US" b="1" dirty="0">
+                <a:solidFill>
+                  <a:srgbClr val="000000"/>
+                </a:solidFill>
+                <a:latin typeface="Times New Roman" panose="02020603050405020304" pitchFamily="18" charset="0"/>
+                <a:cs typeface="Times New Roman" panose="02020603050405020304" pitchFamily="18" charset="0"/>
+              </a:rPr>
+              <a:t>Debug: </a:t>
+            </a:r>
+            <a:r>
+              <a:rPr lang="en-US" dirty="0">
+                <a:solidFill>
+                  <a:srgbClr val="FF0000"/>
+                </a:solidFill>
+                <a:latin typeface="Times New Roman" panose="02020603050405020304" pitchFamily="18" charset="0"/>
+                <a:cs typeface="Times New Roman" panose="02020603050405020304" pitchFamily="18" charset="0"/>
+              </a:rPr>
+              <a:t>MDM JTAG</a:t>
+            </a:r>
+            <a:r>
+              <a:rPr lang="en-US" dirty="0">
+                <a:solidFill>
+                  <a:srgbClr val="000000"/>
+                </a:solidFill>
+                <a:latin typeface="Times New Roman" panose="02020603050405020304" pitchFamily="18" charset="0"/>
+                <a:cs typeface="Times New Roman" panose="02020603050405020304" pitchFamily="18" charset="0"/>
+              </a:rPr>
+              <a:t> — breakpoints, register, memory R/W</a:t>
+            </a:r>
+          </a:p>
+          <a:p>
+            <a:pPr marL="285750" indent="-285750">
+              <a:buFont typeface="Arial" panose="020B0604020202020204" pitchFamily="34" charset="0"/>
+              <a:buChar char="•"/>
+            </a:pPr>
+            <a:endParaRPr lang="en-US" dirty="0">
+              <a:solidFill>
+                <a:srgbClr val="000000"/>
+              </a:solidFill>
+              <a:latin typeface="Times New Roman" panose="02020603050405020304" pitchFamily="18" charset="0"/>
+              <a:cs typeface="Times New Roman" panose="02020603050405020304" pitchFamily="18" charset="0"/>
+            </a:endParaRPr>
+          </a:p>
+          <a:p>
+            <a:pPr marL="285750" indent="-285750">
+              <a:buFont typeface="Arial" panose="020B0604020202020204" pitchFamily="34" charset="0"/>
+              <a:buChar char="•"/>
+            </a:pPr>
+            <a:r>
+              <a:rPr lang="en-US" b="1" dirty="0">
+                <a:solidFill>
+                  <a:srgbClr val="000000"/>
+                </a:solidFill>
+                <a:latin typeface="Times New Roman" panose="02020603050405020304" pitchFamily="18" charset="0"/>
+                <a:cs typeface="Times New Roman" panose="02020603050405020304" pitchFamily="18" charset="0"/>
+              </a:rPr>
+              <a:t>Interrupt: </a:t>
+            </a:r>
+            <a:r>
+              <a:rPr lang="en-US" dirty="0">
+                <a:solidFill>
+                  <a:srgbClr val="000000"/>
+                </a:solidFill>
+                <a:latin typeface="Times New Roman" panose="02020603050405020304" pitchFamily="18" charset="0"/>
+                <a:cs typeface="Times New Roman" panose="02020603050405020304" pitchFamily="18" charset="0"/>
+              </a:rPr>
+              <a:t>AXI INTC, 6 sources (3 Timer + 2 UART + 1 GPIO)</a:t>
+            </a:r>
+            <a:endParaRPr lang="en-US" dirty="0">
+              <a:latin typeface="Times New Roman" panose="02020603050405020304" pitchFamily="18" charset="0"/>
+              <a:cs typeface="Times New Roman" panose="02020603050405020304" pitchFamily="18" charset="0"/>
+            </a:endParaRPr>
+          </a:p>
+        </p:txBody>
+      </p:sp>
+    </p:spTree>
+    <p:extLst>
+      <p:ext uri="{BB962C8B-B14F-4D97-AF65-F5344CB8AC3E}">
+        <p14:creationId xmlns:p14="http://schemas.microsoft.com/office/powerpoint/2010/main" val="4130294994"/>
+      </p:ext>
+    </p:extLst>
+  </p:cSld>
+  <p:clrMapOvr>
+    <a:masterClrMapping/>
+  </p:clrMapOvr>
+</p:sld>
+</file>
+
+<file path=ppt/slides/slide7.xml><?xml version="1.0" encoding="utf-8"?>
+<p:sld xmlns:a="http://schemas.openxmlformats.org/drawingml/2006/main" xmlns:r="http://schemas.openxmlformats.org/officeDocument/2006/relationships" xmlns:p="http://schemas.openxmlformats.org/presentationml/2006/main">
+  <p:cSld>
+    <p:spTree>
+      <p:nvGrpSpPr>
+        <p:cNvPr id="1" name="">
+          <a:extLst>
+            <a:ext uri="{FF2B5EF4-FFF2-40B4-BE49-F238E27FC236}">
               <a16:creationId xmlns:a16="http://schemas.microsoft.com/office/drawing/2014/main" id="{E46C8462-C43F-E9EA-D127-4C195C2A8F13}"/>
             </a:ext>
           </a:extLst>
@@ -21587,7 +22819,7 @@
 </p:sld>
 </file>
 
-<file path=ppt/slides/slide7.xml><?xml version="1.0" encoding="utf-8"?>
+<file path=ppt/slides/slide8.xml><?xml version="1.0" encoding="utf-8"?>
 <p:sld xmlns:a="http://schemas.openxmlformats.org/drawingml/2006/main" xmlns:r="http://schemas.openxmlformats.org/officeDocument/2006/relationships" xmlns:p="http://schemas.openxmlformats.org/presentationml/2006/main">
   <p:cSld>
     <p:spTree>
@@ -23223,7 +24455,7 @@
 </p:sld>
 </file>
 
-<file path=ppt/slides/slide8.xml><?xml version="1.0" encoding="utf-8"?>
+<file path=ppt/slides/slide9.xml><?xml version="1.0" encoding="utf-8"?>
 <p:sld xmlns:a="http://schemas.openxmlformats.org/drawingml/2006/main" xmlns:r="http://schemas.openxmlformats.org/officeDocument/2006/relationships" xmlns:p="http://schemas.openxmlformats.org/presentationml/2006/main">
   <p:cSld>
     <p:spTree>
@@ -23342,818 +24574,6 @@
     <p:extLst>
       <p:ext uri="{BB962C8B-B14F-4D97-AF65-F5344CB8AC3E}">
         <p14:creationId xmlns:p14="http://schemas.microsoft.com/office/powerpoint/2010/main" val="307077018"/>
-      </p:ext>
-    </p:extLst>
-  </p:cSld>
-  <p:clrMapOvr>
-    <a:masterClrMapping/>
-  </p:clrMapOvr>
-</p:sld>
-</file>
-
-<file path=ppt/slides/slide9.xml><?xml version="1.0" encoding="utf-8"?>
-<p:sld xmlns:a="http://schemas.openxmlformats.org/drawingml/2006/main" xmlns:r="http://schemas.openxmlformats.org/officeDocument/2006/relationships" xmlns:p="http://schemas.openxmlformats.org/presentationml/2006/main">
-  <p:cSld>
-    <p:spTree>
-      <p:nvGrpSpPr>
-        <p:cNvPr id="1" name="">
-          <a:extLst>
-            <a:ext uri="{FF2B5EF4-FFF2-40B4-BE49-F238E27FC236}">
-              <a16:creationId xmlns:a16="http://schemas.microsoft.com/office/drawing/2014/main" id="{DC1012D1-F0FF-7EB7-E797-745506D78940}"/>
-            </a:ext>
-          </a:extLst>
-        </p:cNvPr>
-        <p:cNvGrpSpPr/>
-        <p:nvPr/>
-      </p:nvGrpSpPr>
-      <p:grpSpPr>
-        <a:xfrm>
-          <a:off x="0" y="0"/>
-          <a:ext cx="0" cy="0"/>
-          <a:chOff x="0" y="0"/>
-          <a:chExt cx="0" cy="0"/>
-        </a:xfrm>
-      </p:grpSpPr>
-      <p:sp>
-        <p:nvSpPr>
-          <p:cNvPr id="69" name="PlaceHolder 1">
-            <a:extLst>
-              <a:ext uri="{FF2B5EF4-FFF2-40B4-BE49-F238E27FC236}">
-                <a16:creationId xmlns:a16="http://schemas.microsoft.com/office/drawing/2014/main" id="{C6B8070D-A6BE-BFD9-30C0-33B6542AFD2B}"/>
-              </a:ext>
-            </a:extLst>
-          </p:cNvPr>
-          <p:cNvSpPr>
-            <a:spLocks noGrp="1"/>
-          </p:cNvSpPr>
-          <p:nvPr>
-            <p:ph type="title"/>
-          </p:nvPr>
-        </p:nvSpPr>
-        <p:spPr>
-          <a:xfrm>
-            <a:off x="1015920" y="0"/>
-            <a:ext cx="10972080" cy="1142280"/>
-          </a:xfrm>
-          <a:prstGeom prst="rect">
-            <a:avLst/>
-          </a:prstGeom>
-          <a:noFill/>
-          <a:ln w="0">
-            <a:noFill/>
-          </a:ln>
-        </p:spPr>
-        <p:txBody>
-          <a:bodyPr lIns="91440" tIns="45720" rIns="91440" bIns="45720" anchor="ctr">
-            <a:noAutofit/>
-          </a:bodyPr>
-          <a:lstStyle/>
-          <a:p>
-            <a:pPr>
-              <a:lnSpc>
-                <a:spcPct val="100000"/>
-              </a:lnSpc>
-              <a:tabLst>
-                <a:tab pos="0" algn="l"/>
-              </a:tabLst>
-            </a:pPr>
-            <a:r>
-              <a:rPr lang="en-US" sz="4000" b="1" spc="-1" dirty="0">
-                <a:solidFill>
-                  <a:srgbClr val="DDDDDD"/>
-                </a:solidFill>
-                <a:latin typeface="Calibri"/>
-                <a:ea typeface="Calibri"/>
-              </a:rPr>
-              <a:t>UART</a:t>
-            </a:r>
-            <a:endParaRPr lang="en-US" sz="4000" b="0" strike="noStrike" spc="-1" dirty="0">
-              <a:solidFill>
-                <a:srgbClr val="000000"/>
-              </a:solidFill>
-              <a:latin typeface="Arial"/>
-            </a:endParaRPr>
-          </a:p>
-        </p:txBody>
-      </p:sp>
-      <p:sp>
-        <p:nvSpPr>
-          <p:cNvPr id="8" name="矩形 12">
-            <a:extLst>
-              <a:ext uri="{FF2B5EF4-FFF2-40B4-BE49-F238E27FC236}">
-                <a16:creationId xmlns:a16="http://schemas.microsoft.com/office/drawing/2014/main" id="{9C7DCEBE-7CDA-83B2-3426-76BAAAE03F13}"/>
-              </a:ext>
-            </a:extLst>
-          </p:cNvPr>
-          <p:cNvSpPr/>
-          <p:nvPr/>
-        </p:nvSpPr>
-        <p:spPr>
-          <a:xfrm rot="16200000">
-            <a:off x="-1501832" y="3976268"/>
-            <a:ext cx="4367745" cy="254880"/>
-          </a:xfrm>
-          <a:prstGeom prst="rect">
-            <a:avLst/>
-          </a:prstGeom>
-          <a:solidFill>
-            <a:schemeClr val="tx1"/>
-          </a:solidFill>
-          <a:ln>
-            <a:solidFill>
-              <a:srgbClr val="516263"/>
-            </a:solidFill>
-            <a:round/>
-          </a:ln>
-        </p:spPr>
-        <p:style>
-          <a:lnRef idx="2">
-            <a:schemeClr val="accent1">
-              <a:shade val="15000"/>
-            </a:schemeClr>
-          </a:lnRef>
-          <a:fillRef idx="1">
-            <a:schemeClr val="accent1"/>
-          </a:fillRef>
-          <a:effectRef idx="0">
-            <a:schemeClr val="accent1"/>
-          </a:effectRef>
-          <a:fontRef idx="minor"/>
-        </p:style>
-        <p:txBody>
-          <a:bodyPr lIns="90000" tIns="45000" rIns="90000" bIns="45000" anchor="ctr">
-            <a:noAutofit/>
-          </a:bodyPr>
-          <a:lstStyle/>
-          <a:p>
-            <a:pPr algn="ctr">
-              <a:lnSpc>
-                <a:spcPct val="100000"/>
-              </a:lnSpc>
-            </a:pPr>
-            <a:r>
-              <a:rPr lang="en-US" sz="2000" b="0" strike="noStrike" spc="-1">
-                <a:solidFill>
-                  <a:schemeClr val="lt1"/>
-                </a:solidFill>
-                <a:latin typeface="Arial"/>
-                <a:ea typeface="Arial"/>
-              </a:rPr>
-              <a:t>AXI Interconnect (BUS)</a:t>
-            </a:r>
-            <a:endParaRPr lang="en-US" sz="2000" b="0" strike="noStrike" spc="-1">
-              <a:solidFill>
-                <a:srgbClr val="FFFFFF"/>
-              </a:solidFill>
-              <a:latin typeface="Arial"/>
-            </a:endParaRPr>
-          </a:p>
-        </p:txBody>
-      </p:sp>
-      <p:sp>
-        <p:nvSpPr>
-          <p:cNvPr id="15" name="箭號: 上-下雙向 14">
-            <a:extLst>
-              <a:ext uri="{FF2B5EF4-FFF2-40B4-BE49-F238E27FC236}">
-                <a16:creationId xmlns:a16="http://schemas.microsoft.com/office/drawing/2014/main" id="{03CC0EE7-32EF-09E8-560E-B31180B8CE08}"/>
-              </a:ext>
-            </a:extLst>
-          </p:cNvPr>
-          <p:cNvSpPr/>
-          <p:nvPr/>
-        </p:nvSpPr>
-        <p:spPr>
-          <a:xfrm rot="16200000">
-            <a:off x="1233947" y="2016530"/>
-            <a:ext cx="429062" cy="902821"/>
-          </a:xfrm>
-          <a:prstGeom prst="upDownArrow">
-            <a:avLst/>
-          </a:prstGeom>
-          <a:solidFill>
-            <a:schemeClr val="tx1"/>
-          </a:solidFill>
-        </p:spPr>
-        <p:style>
-          <a:lnRef idx="2">
-            <a:schemeClr val="accent1">
-              <a:shade val="15000"/>
-            </a:schemeClr>
-          </a:lnRef>
-          <a:fillRef idx="1">
-            <a:schemeClr val="accent1"/>
-          </a:fillRef>
-          <a:effectRef idx="0">
-            <a:schemeClr val="accent1"/>
-          </a:effectRef>
-          <a:fontRef idx="minor">
-            <a:schemeClr val="lt1"/>
-          </a:fontRef>
-        </p:style>
-        <p:txBody>
-          <a:bodyPr rtlCol="0" anchor="ctr"/>
-          <a:lstStyle/>
-          <a:p>
-            <a:pPr algn="ctr"/>
-            <a:endParaRPr lang="en-US"/>
-          </a:p>
-        </p:txBody>
-      </p:sp>
-      <p:sp>
-        <p:nvSpPr>
-          <p:cNvPr id="16" name="箭號: 上-下雙向 15">
-            <a:extLst>
-              <a:ext uri="{FF2B5EF4-FFF2-40B4-BE49-F238E27FC236}">
-                <a16:creationId xmlns:a16="http://schemas.microsoft.com/office/drawing/2014/main" id="{095BAD7F-A724-D31B-0A50-76863E2DD21D}"/>
-              </a:ext>
-            </a:extLst>
-          </p:cNvPr>
-          <p:cNvSpPr/>
-          <p:nvPr/>
-        </p:nvSpPr>
-        <p:spPr>
-          <a:xfrm rot="16200000">
-            <a:off x="1233948" y="4995398"/>
-            <a:ext cx="429062" cy="902821"/>
-          </a:xfrm>
-          <a:prstGeom prst="upDownArrow">
-            <a:avLst/>
-          </a:prstGeom>
-          <a:solidFill>
-            <a:schemeClr val="tx1"/>
-          </a:solidFill>
-        </p:spPr>
-        <p:style>
-          <a:lnRef idx="2">
-            <a:schemeClr val="accent1">
-              <a:shade val="15000"/>
-            </a:schemeClr>
-          </a:lnRef>
-          <a:fillRef idx="1">
-            <a:schemeClr val="accent1"/>
-          </a:fillRef>
-          <a:effectRef idx="0">
-            <a:schemeClr val="accent1"/>
-          </a:effectRef>
-          <a:fontRef idx="minor">
-            <a:schemeClr val="lt1"/>
-          </a:fontRef>
-        </p:style>
-        <p:txBody>
-          <a:bodyPr rtlCol="0" anchor="ctr"/>
-          <a:lstStyle/>
-          <a:p>
-            <a:pPr algn="ctr"/>
-            <a:endParaRPr lang="en-US"/>
-          </a:p>
-        </p:txBody>
-      </p:sp>
-      <p:sp>
-        <p:nvSpPr>
-          <p:cNvPr id="18" name="矩形: 圓角 23">
-            <a:extLst>
-              <a:ext uri="{FF2B5EF4-FFF2-40B4-BE49-F238E27FC236}">
-                <a16:creationId xmlns:a16="http://schemas.microsoft.com/office/drawing/2014/main" id="{62093F4C-913F-6215-7CAB-2DDC0EB27C95}"/>
-              </a:ext>
-            </a:extLst>
-          </p:cNvPr>
-          <p:cNvSpPr/>
-          <p:nvPr/>
-        </p:nvSpPr>
-        <p:spPr>
-          <a:xfrm>
-            <a:off x="1999995" y="1919835"/>
-            <a:ext cx="1209600" cy="1045080"/>
-          </a:xfrm>
-          <a:prstGeom prst="roundRect">
-            <a:avLst>
-              <a:gd name="adj" fmla="val 16667"/>
-            </a:avLst>
-          </a:prstGeom>
-          <a:solidFill>
-            <a:srgbClr val="92D050"/>
-          </a:solidFill>
-          <a:ln>
-            <a:solidFill>
-              <a:srgbClr val="516263"/>
-            </a:solidFill>
-            <a:round/>
-          </a:ln>
-        </p:spPr>
-        <p:style>
-          <a:lnRef idx="2">
-            <a:schemeClr val="accent1">
-              <a:shade val="15000"/>
-            </a:schemeClr>
-          </a:lnRef>
-          <a:fillRef idx="1">
-            <a:schemeClr val="accent1"/>
-          </a:fillRef>
-          <a:effectRef idx="0">
-            <a:schemeClr val="accent1"/>
-          </a:effectRef>
-          <a:fontRef idx="minor"/>
-        </p:style>
-        <p:txBody>
-          <a:bodyPr lIns="90000" tIns="45000" rIns="90000" bIns="45000" anchor="ctr">
-            <a:noAutofit/>
-          </a:bodyPr>
-          <a:lstStyle/>
-          <a:p>
-            <a:pPr algn="ctr">
-              <a:lnSpc>
-                <a:spcPct val="100000"/>
-              </a:lnSpc>
-            </a:pPr>
-            <a:r>
-              <a:rPr lang="en-US" sz="1400" b="0" strike="noStrike" spc="-1" dirty="0">
-                <a:solidFill>
-                  <a:schemeClr val="dk1"/>
-                </a:solidFill>
-                <a:latin typeface="Arial"/>
-                <a:ea typeface="Arial"/>
-              </a:rPr>
-              <a:t>AXI UART</a:t>
-            </a:r>
-          </a:p>
-          <a:p>
-            <a:pPr algn="ctr">
-              <a:lnSpc>
-                <a:spcPct val="100000"/>
-              </a:lnSpc>
-            </a:pPr>
-            <a:r>
-              <a:rPr lang="en-US" altLang="zh-TW" sz="1400" spc="-1" dirty="0">
-                <a:solidFill>
-                  <a:schemeClr val="dk1"/>
-                </a:solidFill>
-                <a:latin typeface="Arial"/>
-              </a:rPr>
-              <a:t>16550</a:t>
-            </a:r>
-            <a:endParaRPr lang="en-US" sz="1400" b="0" strike="noStrike" spc="-1" dirty="0">
-              <a:solidFill>
-                <a:srgbClr val="000000"/>
-              </a:solidFill>
-              <a:latin typeface="Arial"/>
-            </a:endParaRPr>
-          </a:p>
-        </p:txBody>
-      </p:sp>
-      <p:sp>
-        <p:nvSpPr>
-          <p:cNvPr id="20" name="矩形: 圓角 23">
-            <a:extLst>
-              <a:ext uri="{FF2B5EF4-FFF2-40B4-BE49-F238E27FC236}">
-                <a16:creationId xmlns:a16="http://schemas.microsoft.com/office/drawing/2014/main" id="{F69C6085-5589-54F3-377E-839D25086485}"/>
-              </a:ext>
-            </a:extLst>
-          </p:cNvPr>
-          <p:cNvSpPr/>
-          <p:nvPr/>
-        </p:nvSpPr>
-        <p:spPr>
-          <a:xfrm>
-            <a:off x="1999995" y="4924268"/>
-            <a:ext cx="1209600" cy="1045080"/>
-          </a:xfrm>
-          <a:prstGeom prst="roundRect">
-            <a:avLst>
-              <a:gd name="adj" fmla="val 16667"/>
-            </a:avLst>
-          </a:prstGeom>
-          <a:solidFill>
-            <a:srgbClr val="92D050"/>
-          </a:solidFill>
-          <a:ln>
-            <a:solidFill>
-              <a:srgbClr val="516263"/>
-            </a:solidFill>
-            <a:round/>
-          </a:ln>
-        </p:spPr>
-        <p:style>
-          <a:lnRef idx="2">
-            <a:schemeClr val="accent1">
-              <a:shade val="15000"/>
-            </a:schemeClr>
-          </a:lnRef>
-          <a:fillRef idx="1">
-            <a:schemeClr val="accent1"/>
-          </a:fillRef>
-          <a:effectRef idx="0">
-            <a:schemeClr val="accent1"/>
-          </a:effectRef>
-          <a:fontRef idx="minor"/>
-        </p:style>
-        <p:txBody>
-          <a:bodyPr lIns="90000" tIns="45000" rIns="90000" bIns="45000" anchor="ctr">
-            <a:noAutofit/>
-          </a:bodyPr>
-          <a:lstStyle/>
-          <a:p>
-            <a:pPr algn="ctr">
-              <a:lnSpc>
-                <a:spcPct val="100000"/>
-              </a:lnSpc>
-            </a:pPr>
-            <a:r>
-              <a:rPr lang="en-US" sz="1400" b="0" strike="noStrike" spc="-1" dirty="0">
-                <a:solidFill>
-                  <a:schemeClr val="dk1"/>
-                </a:solidFill>
-                <a:latin typeface="Arial"/>
-                <a:ea typeface="Arial"/>
-              </a:rPr>
-              <a:t>AXI UART</a:t>
-            </a:r>
-          </a:p>
-          <a:p>
-            <a:pPr algn="ctr">
-              <a:lnSpc>
-                <a:spcPct val="100000"/>
-              </a:lnSpc>
-            </a:pPr>
-            <a:r>
-              <a:rPr lang="en-US" altLang="zh-TW" sz="1400" spc="-1" dirty="0">
-                <a:solidFill>
-                  <a:schemeClr val="dk1"/>
-                </a:solidFill>
-                <a:latin typeface="Arial"/>
-              </a:rPr>
-              <a:t>16550 * 2</a:t>
-            </a:r>
-            <a:endParaRPr lang="en-US" sz="1400" b="0" strike="noStrike" spc="-1" dirty="0">
-              <a:solidFill>
-                <a:srgbClr val="000000"/>
-              </a:solidFill>
-              <a:latin typeface="Arial"/>
-            </a:endParaRPr>
-          </a:p>
-        </p:txBody>
-      </p:sp>
-      <p:sp>
-        <p:nvSpPr>
-          <p:cNvPr id="21" name="文字方塊 22">
-            <a:extLst>
-              <a:ext uri="{FF2B5EF4-FFF2-40B4-BE49-F238E27FC236}">
-                <a16:creationId xmlns:a16="http://schemas.microsoft.com/office/drawing/2014/main" id="{3BD316AC-9B5D-106F-D34F-74A87F33A669}"/>
-              </a:ext>
-            </a:extLst>
-          </p:cNvPr>
-          <p:cNvSpPr/>
-          <p:nvPr/>
-        </p:nvSpPr>
-        <p:spPr>
-          <a:xfrm>
-            <a:off x="3799002" y="2289213"/>
-            <a:ext cx="2064989" cy="306323"/>
-          </a:xfrm>
-          <a:prstGeom prst="rect">
-            <a:avLst/>
-          </a:prstGeom>
-          <a:noFill/>
-          <a:ln w="0">
-            <a:noFill/>
-          </a:ln>
-        </p:spPr>
-        <p:style>
-          <a:lnRef idx="0">
-            <a:scrgbClr r="0" g="0" b="0"/>
-          </a:lnRef>
-          <a:fillRef idx="0">
-            <a:scrgbClr r="0" g="0" b="0"/>
-          </a:fillRef>
-          <a:effectRef idx="0">
-            <a:scrgbClr r="0" g="0" b="0"/>
-          </a:effectRef>
-          <a:fontRef idx="minor"/>
-        </p:style>
-        <p:txBody>
-          <a:bodyPr wrap="square" lIns="90000" tIns="45000" rIns="90000" bIns="45000" anchor="t">
-            <a:spAutoFit/>
-          </a:bodyPr>
-          <a:lstStyle/>
-          <a:p>
-            <a:pPr algn="ctr"/>
-            <a:r>
-              <a:rPr lang="en-US" sz="1400" b="0" strike="noStrike" spc="-1" dirty="0">
-                <a:solidFill>
-                  <a:srgbClr val="000000"/>
-                </a:solidFill>
-                <a:latin typeface="Arial"/>
-              </a:rPr>
-              <a:t>UART_R</a:t>
-            </a:r>
-            <a:r>
-              <a:rPr lang="en-US" sz="1400" spc="-1" dirty="0">
-                <a:solidFill>
-                  <a:srgbClr val="000000"/>
-                </a:solidFill>
-                <a:latin typeface="Arial"/>
-              </a:rPr>
-              <a:t>X / UART_TX</a:t>
-            </a:r>
-            <a:endParaRPr lang="en-US" sz="1400" b="0" strike="noStrike" spc="-1" dirty="0">
-              <a:solidFill>
-                <a:srgbClr val="000000"/>
-              </a:solidFill>
-              <a:latin typeface="Arial"/>
-            </a:endParaRPr>
-          </a:p>
-        </p:txBody>
-      </p:sp>
-      <p:cxnSp>
-        <p:nvCxnSpPr>
-          <p:cNvPr id="23" name="直線單箭頭接點 14">
-            <a:extLst>
-              <a:ext uri="{FF2B5EF4-FFF2-40B4-BE49-F238E27FC236}">
-                <a16:creationId xmlns:a16="http://schemas.microsoft.com/office/drawing/2014/main" id="{53BD1B6E-8B14-61E5-B5D3-FA1BEEE1FC87}"/>
-              </a:ext>
-            </a:extLst>
-          </p:cNvPr>
-          <p:cNvCxnSpPr>
-            <a:cxnSpLocks/>
-            <a:stCxn id="20" idx="3"/>
-            <a:endCxn id="35" idx="1"/>
-          </p:cNvCxnSpPr>
-          <p:nvPr/>
-        </p:nvCxnSpPr>
-        <p:spPr>
-          <a:xfrm>
-            <a:off x="3209595" y="5446808"/>
-            <a:ext cx="599508" cy="0"/>
-          </a:xfrm>
-          <a:prstGeom prst="straightConnector1">
-            <a:avLst/>
-          </a:prstGeom>
-          <a:ln w="0">
-            <a:solidFill>
-              <a:srgbClr val="000000"/>
-            </a:solidFill>
-            <a:tailEnd type="triangle" w="med" len="med"/>
-          </a:ln>
-        </p:spPr>
-      </p:cxnSp>
-      <p:cxnSp>
-        <p:nvCxnSpPr>
-          <p:cNvPr id="32" name="直線單箭頭接點 14">
-            <a:extLst>
-              <a:ext uri="{FF2B5EF4-FFF2-40B4-BE49-F238E27FC236}">
-                <a16:creationId xmlns:a16="http://schemas.microsoft.com/office/drawing/2014/main" id="{7D30910F-D8E7-2E59-AD42-746234317054}"/>
-              </a:ext>
-            </a:extLst>
-          </p:cNvPr>
-          <p:cNvCxnSpPr>
-            <a:cxnSpLocks/>
-            <a:stCxn id="18" idx="3"/>
-            <a:endCxn id="21" idx="1"/>
-          </p:cNvCxnSpPr>
-          <p:nvPr/>
-        </p:nvCxnSpPr>
-        <p:spPr>
-          <a:xfrm>
-            <a:off x="3209595" y="2442375"/>
-            <a:ext cx="589407" cy="0"/>
-          </a:xfrm>
-          <a:prstGeom prst="straightConnector1">
-            <a:avLst/>
-          </a:prstGeom>
-          <a:ln w="0">
-            <a:solidFill>
-              <a:srgbClr val="000000"/>
-            </a:solidFill>
-            <a:tailEnd type="triangle" w="med" len="med"/>
-          </a:ln>
-        </p:spPr>
-      </p:cxnSp>
-      <p:sp>
-        <p:nvSpPr>
-          <p:cNvPr id="35" name="文字方塊 22">
-            <a:extLst>
-              <a:ext uri="{FF2B5EF4-FFF2-40B4-BE49-F238E27FC236}">
-                <a16:creationId xmlns:a16="http://schemas.microsoft.com/office/drawing/2014/main" id="{7CBA17DF-F2D8-945C-758E-C5116574D8E7}"/>
-              </a:ext>
-            </a:extLst>
-          </p:cNvPr>
-          <p:cNvSpPr/>
-          <p:nvPr/>
-        </p:nvSpPr>
-        <p:spPr>
-          <a:xfrm>
-            <a:off x="3809103" y="5293646"/>
-            <a:ext cx="1182012" cy="306323"/>
-          </a:xfrm>
-          <a:prstGeom prst="rect">
-            <a:avLst/>
-          </a:prstGeom>
-          <a:noFill/>
-          <a:ln w="0">
-            <a:noFill/>
-          </a:ln>
-        </p:spPr>
-        <p:style>
-          <a:lnRef idx="0">
-            <a:scrgbClr r="0" g="0" b="0"/>
-          </a:lnRef>
-          <a:fillRef idx="0">
-            <a:scrgbClr r="0" g="0" b="0"/>
-          </a:fillRef>
-          <a:effectRef idx="0">
-            <a:scrgbClr r="0" g="0" b="0"/>
-          </a:effectRef>
-          <a:fontRef idx="minor"/>
-        </p:style>
-        <p:txBody>
-          <a:bodyPr wrap="square" lIns="90000" tIns="45000" rIns="90000" bIns="45000" anchor="t">
-            <a:spAutoFit/>
-          </a:bodyPr>
-          <a:lstStyle/>
-          <a:p>
-            <a:pPr algn="ctr"/>
-            <a:r>
-              <a:rPr lang="en-US" sz="1400" spc="-1" dirty="0">
-                <a:solidFill>
-                  <a:srgbClr val="000000"/>
-                </a:solidFill>
-              </a:rPr>
-              <a:t>USB-UART</a:t>
-            </a:r>
-            <a:endParaRPr lang="en-US" sz="1400" b="0" strike="noStrike" spc="-1" dirty="0">
-              <a:solidFill>
-                <a:srgbClr val="000000"/>
-              </a:solidFill>
-              <a:latin typeface="Arial"/>
-            </a:endParaRPr>
-          </a:p>
-        </p:txBody>
-      </p:sp>
-      <p:sp>
-        <p:nvSpPr>
-          <p:cNvPr id="41" name="文字方塊 40">
-            <a:extLst>
-              <a:ext uri="{FF2B5EF4-FFF2-40B4-BE49-F238E27FC236}">
-                <a16:creationId xmlns:a16="http://schemas.microsoft.com/office/drawing/2014/main" id="{10F817FE-BFD2-0EF6-3A08-B7A51E219AAA}"/>
-              </a:ext>
-            </a:extLst>
-          </p:cNvPr>
-          <p:cNvSpPr txBox="1"/>
-          <p:nvPr/>
-        </p:nvSpPr>
-        <p:spPr>
-          <a:xfrm>
-            <a:off x="5863991" y="2025573"/>
-            <a:ext cx="6094428" cy="2862322"/>
-          </a:xfrm>
-          <a:prstGeom prst="rect">
-            <a:avLst/>
-          </a:prstGeom>
-          <a:noFill/>
-        </p:spPr>
-        <p:txBody>
-          <a:bodyPr wrap="square">
-            <a:spAutoFit/>
-          </a:bodyPr>
-          <a:lstStyle/>
-          <a:p>
-            <a:pPr>
-              <a:buNone/>
-            </a:pPr>
-            <a:r>
-              <a:rPr lang="en-US" b="1" dirty="0">
-                <a:latin typeface="Times New Roman" panose="02020603050405020304" pitchFamily="18" charset="0"/>
-                <a:cs typeface="Times New Roman" panose="02020603050405020304" pitchFamily="18" charset="0"/>
-              </a:rPr>
-              <a:t>2 × AXI UART 16550 Instances:</a:t>
-            </a:r>
-            <a:endParaRPr lang="en-US" dirty="0">
-              <a:latin typeface="Times New Roman" panose="02020603050405020304" pitchFamily="18" charset="0"/>
-              <a:cs typeface="Times New Roman" panose="02020603050405020304" pitchFamily="18" charset="0"/>
-            </a:endParaRPr>
-          </a:p>
-          <a:p>
-            <a:pPr>
-              <a:buNone/>
-            </a:pPr>
-            <a:endParaRPr lang="en-US" b="1" dirty="0">
-              <a:latin typeface="Times New Roman" panose="02020603050405020304" pitchFamily="18" charset="0"/>
-              <a:cs typeface="Times New Roman" panose="02020603050405020304" pitchFamily="18" charset="0"/>
-            </a:endParaRPr>
-          </a:p>
-          <a:p>
-            <a:pPr>
-              <a:buNone/>
-            </a:pPr>
-            <a:r>
-              <a:rPr lang="en-US" b="1" dirty="0">
-                <a:latin typeface="Times New Roman" panose="02020603050405020304" pitchFamily="18" charset="0"/>
-                <a:cs typeface="Times New Roman" panose="02020603050405020304" pitchFamily="18" charset="0"/>
-              </a:rPr>
-              <a:t>uart_USB</a:t>
-            </a:r>
-            <a:r>
-              <a:rPr lang="zh-TW" altLang="en-US" b="1" dirty="0">
-                <a:latin typeface="Times New Roman" panose="02020603050405020304" pitchFamily="18" charset="0"/>
-                <a:cs typeface="Times New Roman" panose="02020603050405020304" pitchFamily="18" charset="0"/>
-              </a:rPr>
-              <a:t> </a:t>
-            </a:r>
-            <a:r>
-              <a:rPr lang="en-US" b="1" dirty="0">
-                <a:latin typeface="Times New Roman" panose="02020603050405020304" pitchFamily="18" charset="0"/>
-                <a:cs typeface="Times New Roman" panose="02020603050405020304" pitchFamily="18" charset="0"/>
-              </a:rPr>
-              <a:t>— Console / Debug</a:t>
-            </a:r>
-            <a:endParaRPr lang="en-US" dirty="0">
-              <a:latin typeface="Times New Roman" panose="02020603050405020304" pitchFamily="18" charset="0"/>
-              <a:cs typeface="Times New Roman" panose="02020603050405020304" pitchFamily="18" charset="0"/>
-            </a:endParaRPr>
-          </a:p>
-          <a:p>
-            <a:pPr lvl="1">
-              <a:buFont typeface="Arial" panose="020B0604020202020204" pitchFamily="34" charset="0"/>
-              <a:buChar char="•"/>
-            </a:pPr>
-            <a:r>
-              <a:rPr lang="en-US" dirty="0">
-                <a:latin typeface="Times New Roman" panose="02020603050405020304" pitchFamily="18" charset="0"/>
-                <a:cs typeface="Times New Roman" panose="02020603050405020304" pitchFamily="18" charset="0"/>
-              </a:rPr>
-              <a:t>Connected to on-board USB-UART via Micro-USB (J3)</a:t>
-            </a:r>
-          </a:p>
-          <a:p>
-            <a:pPr lvl="1">
-              <a:buFont typeface="Arial" panose="020B0604020202020204" pitchFamily="34" charset="0"/>
-              <a:buChar char="•"/>
-            </a:pPr>
-            <a:r>
-              <a:rPr lang="en-US" dirty="0">
-                <a:latin typeface="Times New Roman" panose="02020603050405020304" pitchFamily="18" charset="0"/>
-                <a:cs typeface="Times New Roman" panose="02020603050405020304" pitchFamily="18" charset="0"/>
-              </a:rPr>
-              <a:t>No DIP pin exposed — accessed through USB cable</a:t>
-            </a:r>
-          </a:p>
-          <a:p>
-            <a:pPr lvl="1">
-              <a:buFont typeface="Arial" panose="020B0604020202020204" pitchFamily="34" charset="0"/>
-              <a:buChar char="•"/>
-            </a:pPr>
-            <a:endParaRPr lang="en-US" dirty="0">
-              <a:latin typeface="Times New Roman" panose="02020603050405020304" pitchFamily="18" charset="0"/>
-              <a:cs typeface="Times New Roman" panose="02020603050405020304" pitchFamily="18" charset="0"/>
-            </a:endParaRPr>
-          </a:p>
-          <a:p>
-            <a:pPr>
-              <a:buNone/>
-            </a:pPr>
-            <a:r>
-              <a:rPr lang="en-US" b="1" dirty="0">
-                <a:latin typeface="Times New Roman" panose="02020603050405020304" pitchFamily="18" charset="0"/>
-                <a:cs typeface="Times New Roman" panose="02020603050405020304" pitchFamily="18" charset="0"/>
-              </a:rPr>
-              <a:t>uart_1 — External Communication</a:t>
-            </a:r>
-            <a:endParaRPr lang="en-US" dirty="0">
-              <a:latin typeface="Times New Roman" panose="02020603050405020304" pitchFamily="18" charset="0"/>
-              <a:cs typeface="Times New Roman" panose="02020603050405020304" pitchFamily="18" charset="0"/>
-            </a:endParaRPr>
-          </a:p>
-          <a:p>
-            <a:pPr lvl="1">
-              <a:buFont typeface="Arial" panose="020B0604020202020204" pitchFamily="34" charset="0"/>
-              <a:buChar char="•"/>
-            </a:pPr>
-            <a:r>
-              <a:rPr lang="en-US" dirty="0">
-                <a:latin typeface="Times New Roman" panose="02020603050405020304" pitchFamily="18" charset="0"/>
-                <a:cs typeface="Times New Roman" panose="02020603050405020304" pitchFamily="18" charset="0"/>
-              </a:rPr>
-              <a:t>TX/RX routed to DIP Pin 11 / Pin 12</a:t>
-            </a:r>
-          </a:p>
-          <a:p>
-            <a:pPr lvl="1">
-              <a:buFont typeface="Arial" panose="020B0604020202020204" pitchFamily="34" charset="0"/>
-              <a:buChar char="•"/>
-            </a:pPr>
-            <a:r>
-              <a:rPr lang="en-US" dirty="0">
-                <a:latin typeface="Times New Roman" panose="02020603050405020304" pitchFamily="18" charset="0"/>
-                <a:cs typeface="Times New Roman" panose="02020603050405020304" pitchFamily="18" charset="0"/>
-              </a:rPr>
-              <a:t>Available for connecting external devices (sensors, modules, another MCU)</a:t>
-            </a:r>
-          </a:p>
-        </p:txBody>
-      </p:sp>
-    </p:spTree>
-    <p:extLst>
-      <p:ext uri="{BB962C8B-B14F-4D97-AF65-F5344CB8AC3E}">
-        <p14:creationId xmlns:p14="http://schemas.microsoft.com/office/powerpoint/2010/main" val="3879458922"/>
       </p:ext>
     </p:extLst>
   </p:cSld>

</xml_diff>